<commit_message>
Submission checklist: Excel record book, primary focus and KYC in the report, performance slide and 25-minute speaker notes
Co-Authored-By: Claude Opus 5.5 <noreply@anthropic.com>
Claude-Session: https://claude.ai/code/session_01PCmAkTtoQHaefAhZET8xvj
</commit_message>
<xml_diff>
--- a/presentation/presentation.pptx
+++ b/presentation/presentation.pptx
@@ -24,6 +24,7 @@
     <p:sldId id="269" r:id="rId20"/>
     <p:sldId id="270" r:id="rId21"/>
     <p:sldId id="271" r:id="rId22"/>
+    <p:sldId id="276" r:id="rId27"/>
     <p:sldId id="272" r:id="rId23"/>
     <p:sldId id="273" r:id="rId24"/>
     <p:sldId id="274" r:id="rId25"/>
@@ -2345,7 +2346,7 @@
           <a:lstStyle/>
           <a:p>
             <a:r>
-              <a:t>Title. One audit, three questions: does LLM fund advice follow the investor, is it suitable, and does a prompt-level suitability protocol help?</a:t>
+              <a:t>[0:00-0:45] Title. We audited three Chinese chatbots as fund advisers: do they tailor advice to the client, is it suitable under China's rules, and does a suitability protocol in the prompt help?</a:t>
             </a:r>
           </a:p>
         </p:txBody>
@@ -2415,7 +2416,7 @@
           <a:lstStyle/>
           <a:p>
             <a:r>
-              <a:t>Equity rises steeply with the stated risk class in every model and prompt. Horizon matters mainly below one year; age has almost no effect. Source: T05, T09, T10.</a:t>
+              <a:t>[11:15-13:15] Risk tolerance drives the portfolio: partial eta squared 0.66-0.83. Horizon works as a switch below one year. Age barely matters, against life-cycle theory.</a:t>
             </a:r>
           </a:p>
         </p:txBody>
@@ -2485,7 +2486,7 @@
           <a:lstStyle/>
           <a:p>
             <a:r>
-              <a:t>Ratings were shown in the prompt. No menu fund is R5, so C4-C5 investors cannot breach the rating rule. Source: T12, T22, T17, T11.</a:t>
+              <a:t>[13:15-15:45] The key finding: although ratings are in the prompt, 82.5-85.8% of BASE replies to C1-C3 clients contain a fund above the ceiling, mostly bond funds for C1. Aggressive clients with 1-3 year horizons get about 78% equity against a 30% cap. Losses beyond the stated limit were rare, but the window was benign for bonds.</a:t>
             </a:r>
           </a:p>
         </p:txBody>
@@ -2555,7 +2556,7 @@
           <a:lstStyle/>
           <a:p>
             <a:r>
-              <a:t>Paired within investor. The protocol cuts breaches in every model, most for Kimi, yet many correctly classified clients still get a fund above their class. Source: T22, T13, T25, T17, T14.</a:t>
+              <a:t>[15:45-18:00] The protocol cuts rating breaches in every model, by 9.5, 11.1 and 24.5 points, and the models flag the conflict almost every time. But compliance does not follow: many clients the model classified correctly still get a fund above their class. Under SUIT the models differ; Kimi responds most.</a:t>
             </a:r>
           </a:p>
         </p:txBody>
@@ -2625,7 +2626,427 @@
           <a:lstStyle/>
           <a:p>
             <a:r>
-              <a:t>40 investors asked three times; ten anchors varied one attribute at a time. Source: T15, T16.</a:t>
+              <a:t>[18:00-19:30] Same question three times: equity is stable, fund choices are not, and the breach verdict changes for up to 17.5% of clients. Probes: the stated horizon on its own moves equity only 1-4 points.</a:t>
+            </a:r>
+          </a:p>
+        </p:txBody>
+      </p:sp>
+      <p:sp>
+        <p:nvSpPr>
+          <p:cNvPr id="4" name="Slide Number Placeholder 3"/>
+          <p:cNvSpPr>
+            <a:spLocks noGrp="1"/>
+          </p:cNvSpPr>
+          <p:nvPr>
+            <p:ph type="sldNum" idx="5" sz="quarter"/>
+          </p:nvPr>
+        </p:nvSpPr>
+        <p:spPr/>
+      </p:sp>
+    </p:spTree>
+  </p:cSld>
+  <p:clrMapOvr>
+    <a:masterClrMapping/>
+  </p:clrMapOvr>
+</p:notes>
+</file>
+
+<file path=ppt/notesSlides/notesSlide14.xml><?xml version="1.0" encoding="utf-8"?>
+<p:notes xmlns:a="http://schemas.openxmlformats.org/drawingml/2006/main" xmlns:p="http://schemas.openxmlformats.org/presentationml/2006/main" xmlns:r="http://schemas.openxmlformats.org/officeDocument/2006/relationships">
+  <p:cSld>
+    <p:spTree>
+      <p:nvGrpSpPr>
+        <p:cNvPr id="1" name=""/>
+        <p:cNvGrpSpPr/>
+        <p:nvPr/>
+      </p:nvGrpSpPr>
+      <p:grpSpPr>
+        <a:xfrm>
+          <a:off x="0" y="0"/>
+          <a:ext cx="0" cy="0"/>
+          <a:chOff x="0" y="0"/>
+          <a:chExt cx="0" cy="0"/>
+        </a:xfrm>
+      </p:grpSpPr>
+      <p:sp>
+        <p:nvSpPr>
+          <p:cNvPr id="2" name="Slide Image Placeholder 1"/>
+          <p:cNvSpPr>
+            <a:spLocks noGrp="1"/>
+          </p:cNvSpPr>
+          <p:nvPr>
+            <p:ph type="sldImg" idx="2"/>
+          </p:nvPr>
+        </p:nvSpPr>
+        <p:spPr/>
+      </p:sp>
+      <p:sp>
+        <p:nvSpPr>
+          <p:cNvPr id="3" name="Notes Placeholder 2"/>
+          <p:cNvSpPr>
+            <a:spLocks noGrp="1"/>
+          </p:cNvSpPr>
+          <p:nvPr>
+            <p:ph type="body" idx="3" sz="quarter"/>
+          </p:nvPr>
+        </p:nvSpPr>
+        <p:spPr/>
+        <p:txBody>
+          <a:bodyPr/>
+          <a:lstStyle/>
+          <a:p>
+            <a:r>
+              <a:t>[1:15-1:30] Part 1: why this needs an audit.</a:t>
+            </a:r>
+          </a:p>
+        </p:txBody>
+      </p:sp>
+      <p:sp>
+        <p:nvSpPr>
+          <p:cNvPr id="4" name="Slide Number Placeholder 3"/>
+          <p:cNvSpPr>
+            <a:spLocks noGrp="1"/>
+          </p:cNvSpPr>
+          <p:nvPr>
+            <p:ph type="sldNum" idx="5" sz="quarter"/>
+          </p:nvPr>
+        </p:nvSpPr>
+        <p:spPr/>
+      </p:sp>
+    </p:spTree>
+  </p:cSld>
+  <p:clrMapOvr>
+    <a:masterClrMapping/>
+  </p:clrMapOvr>
+</p:notes>
+</file>
+
+<file path=ppt/notesSlides/notesSlide15.xml><?xml version="1.0" encoding="utf-8"?>
+<p:notes xmlns:a="http://schemas.openxmlformats.org/drawingml/2006/main" xmlns:p="http://schemas.openxmlformats.org/presentationml/2006/main" xmlns:r="http://schemas.openxmlformats.org/officeDocument/2006/relationships">
+  <p:cSld>
+    <p:spTree>
+      <p:nvGrpSpPr>
+        <p:cNvPr id="1" name=""/>
+        <p:cNvGrpSpPr/>
+        <p:nvPr/>
+      </p:nvGrpSpPr>
+      <p:grpSpPr>
+        <a:xfrm>
+          <a:off x="0" y="0"/>
+          <a:ext cx="0" cy="0"/>
+          <a:chOff x="0" y="0"/>
+          <a:chExt cx="0" cy="0"/>
+        </a:xfrm>
+      </p:grpSpPr>
+      <p:sp>
+        <p:nvSpPr>
+          <p:cNvPr id="2" name="Slide Image Placeholder 1"/>
+          <p:cNvSpPr>
+            <a:spLocks noGrp="1"/>
+          </p:cNvSpPr>
+          <p:nvPr>
+            <p:ph type="sldImg" idx="2"/>
+          </p:nvPr>
+        </p:nvSpPr>
+        <p:spPr/>
+      </p:sp>
+      <p:sp>
+        <p:nvSpPr>
+          <p:cNvPr id="3" name="Notes Placeholder 2"/>
+          <p:cNvSpPr>
+            <a:spLocks noGrp="1"/>
+          </p:cNvSpPr>
+          <p:nvPr>
+            <p:ph type="body" idx="3" sz="quarter"/>
+          </p:nvPr>
+        </p:nvSpPr>
+        <p:spPr/>
+        <p:txBody>
+          <a:bodyPr/>
+          <a:lstStyle/>
+          <a:p>
+            <a:r>
+              <a:t>[4:15-4:30] Part 2: how we built the experiment.</a:t>
+            </a:r>
+          </a:p>
+        </p:txBody>
+      </p:sp>
+      <p:sp>
+        <p:nvSpPr>
+          <p:cNvPr id="4" name="Slide Number Placeholder 3"/>
+          <p:cNvSpPr>
+            <a:spLocks noGrp="1"/>
+          </p:cNvSpPr>
+          <p:nvPr>
+            <p:ph type="sldNum" idx="5" sz="quarter"/>
+          </p:nvPr>
+        </p:nvSpPr>
+        <p:spPr/>
+      </p:sp>
+    </p:spTree>
+  </p:cSld>
+  <p:clrMapOvr>
+    <a:masterClrMapping/>
+  </p:clrMapOvr>
+</p:notes>
+</file>
+
+<file path=ppt/notesSlides/notesSlide16.xml><?xml version="1.0" encoding="utf-8"?>
+<p:notes xmlns:a="http://schemas.openxmlformats.org/drawingml/2006/main" xmlns:p="http://schemas.openxmlformats.org/presentationml/2006/main" xmlns:r="http://schemas.openxmlformats.org/officeDocument/2006/relationships">
+  <p:cSld>
+    <p:spTree>
+      <p:nvGrpSpPr>
+        <p:cNvPr id="1" name=""/>
+        <p:cNvGrpSpPr/>
+        <p:nvPr/>
+      </p:nvGrpSpPr>
+      <p:grpSpPr>
+        <a:xfrm>
+          <a:off x="0" y="0"/>
+          <a:ext cx="0" cy="0"/>
+          <a:chOff x="0" y="0"/>
+          <a:chExt cx="0" cy="0"/>
+        </a:xfrm>
+      </p:grpSpPr>
+      <p:sp>
+        <p:nvSpPr>
+          <p:cNvPr id="2" name="Slide Image Placeholder 1"/>
+          <p:cNvSpPr>
+            <a:spLocks noGrp="1"/>
+          </p:cNvSpPr>
+          <p:nvPr>
+            <p:ph type="sldImg" idx="2"/>
+          </p:nvPr>
+        </p:nvSpPr>
+        <p:spPr/>
+      </p:sp>
+      <p:sp>
+        <p:nvSpPr>
+          <p:cNvPr id="3" name="Notes Placeholder 2"/>
+          <p:cNvSpPr>
+            <a:spLocks noGrp="1"/>
+          </p:cNvSpPr>
+          <p:nvPr>
+            <p:ph type="body" idx="3" sz="quarter"/>
+          </p:nvPr>
+        </p:nvSpPr>
+        <p:spPr/>
+        <p:txBody>
+          <a:bodyPr/>
+          <a:lstStyle/>
+          <a:p>
+            <a:r>
+              <a:t>[11:00-11:15] Part 3: results.</a:t>
+            </a:r>
+          </a:p>
+        </p:txBody>
+      </p:sp>
+      <p:sp>
+        <p:nvSpPr>
+          <p:cNvPr id="4" name="Slide Number Placeholder 3"/>
+          <p:cNvSpPr>
+            <a:spLocks noGrp="1"/>
+          </p:cNvSpPr>
+          <p:nvPr>
+            <p:ph type="sldNum" idx="5" sz="quarter"/>
+          </p:nvPr>
+        </p:nvSpPr>
+        <p:spPr/>
+      </p:sp>
+    </p:spTree>
+  </p:cSld>
+  <p:clrMapOvr>
+    <a:masterClrMapping/>
+  </p:clrMapOvr>
+</p:notes>
+</file>
+
+<file path=ppt/notesSlides/notesSlide17.xml><?xml version="1.0" encoding="utf-8"?>
+<p:notes xmlns:a="http://schemas.openxmlformats.org/drawingml/2006/main" xmlns:p="http://schemas.openxmlformats.org/presentationml/2006/main" xmlns:r="http://schemas.openxmlformats.org/officeDocument/2006/relationships">
+  <p:cSld>
+    <p:spTree>
+      <p:nvGrpSpPr>
+        <p:cNvPr id="1" name=""/>
+        <p:cNvGrpSpPr/>
+        <p:nvPr/>
+      </p:nvGrpSpPr>
+      <p:grpSpPr>
+        <a:xfrm>
+          <a:off x="0" y="0"/>
+          <a:ext cx="0" cy="0"/>
+          <a:chOff x="0" y="0"/>
+          <a:chExt cx="0" cy="0"/>
+        </a:xfrm>
+      </p:grpSpPr>
+      <p:sp>
+        <p:nvSpPr>
+          <p:cNvPr id="2" name="Slide Image Placeholder 1"/>
+          <p:cNvSpPr>
+            <a:spLocks noGrp="1"/>
+          </p:cNvSpPr>
+          <p:nvPr>
+            <p:ph type="sldImg" idx="2"/>
+          </p:nvPr>
+        </p:nvSpPr>
+        <p:spPr/>
+      </p:sp>
+      <p:sp>
+        <p:nvSpPr>
+          <p:cNvPr id="3" name="Notes Placeholder 2"/>
+          <p:cNvSpPr>
+            <a:spLocks noGrp="1"/>
+          </p:cNvSpPr>
+          <p:nvPr>
+            <p:ph type="body" idx="3" sz="quarter"/>
+          </p:nvPr>
+        </p:nvSpPr>
+        <p:spPr/>
+        <p:txBody>
+          <a:bodyPr/>
+          <a:lstStyle/>
+          <a:p>
+            <a:r>
+              <a:t>[19:30-21:30] Performance over Nov 2021 - Sep 2026, a weak period for Chinese equities. Most portfolios beat a 60/40 mix on the Sharpe ratio, and aggressive clients' portfolios beat a rating-compliant model portfolio. For cautious clients the extra return came from non-permitted funds: performance and compliance pulled apart. Fees are negligible. The model portfolio is our stylised robo ladder, not a commercial robo record.</a:t>
+            </a:r>
+          </a:p>
+        </p:txBody>
+      </p:sp>
+      <p:sp>
+        <p:nvSpPr>
+          <p:cNvPr id="4" name="Slide Number Placeholder 3"/>
+          <p:cNvSpPr>
+            <a:spLocks noGrp="1"/>
+          </p:cNvSpPr>
+          <p:nvPr>
+            <p:ph type="sldNum" idx="5" sz="quarter"/>
+          </p:nvPr>
+        </p:nvSpPr>
+        <p:spPr/>
+      </p:sp>
+    </p:spTree>
+  </p:cSld>
+  <p:clrMapOvr>
+    <a:masterClrMapping/>
+  </p:clrMapOvr>
+</p:notes>
+</file>
+
+<file path=ppt/notesSlides/notesSlide18.xml><?xml version="1.0" encoding="utf-8"?>
+<p:notes xmlns:a="http://schemas.openxmlformats.org/drawingml/2006/main" xmlns:p="http://schemas.openxmlformats.org/presentationml/2006/main" xmlns:r="http://schemas.openxmlformats.org/officeDocument/2006/relationships">
+  <p:cSld>
+    <p:spTree>
+      <p:nvGrpSpPr>
+        <p:cNvPr id="1" name=""/>
+        <p:cNvGrpSpPr/>
+        <p:nvPr/>
+      </p:nvGrpSpPr>
+      <p:grpSpPr>
+        <a:xfrm>
+          <a:off x="0" y="0"/>
+          <a:ext cx="0" cy="0"/>
+          <a:chOff x="0" y="0"/>
+          <a:chExt cx="0" cy="0"/>
+        </a:xfrm>
+      </p:grpSpPr>
+      <p:sp>
+        <p:nvSpPr>
+          <p:cNvPr id="2" name="Slide Image Placeholder 1"/>
+          <p:cNvSpPr>
+            <a:spLocks noGrp="1"/>
+          </p:cNvSpPr>
+          <p:nvPr>
+            <p:ph type="sldImg" idx="2"/>
+          </p:nvPr>
+        </p:nvSpPr>
+        <p:spPr/>
+      </p:sp>
+      <p:sp>
+        <p:nvSpPr>
+          <p:cNvPr id="3" name="Notes Placeholder 2"/>
+          <p:cNvSpPr>
+            <a:spLocks noGrp="1"/>
+          </p:cNvSpPr>
+          <p:nvPr>
+            <p:ph type="body" idx="3" sz="quarter"/>
+          </p:nvPr>
+        </p:nvSpPr>
+        <p:spPr/>
+        <p:txBody>
+          <a:bodyPr/>
+          <a:lstStyle/>
+          <a:p>
+            <a:r>
+              <a:t>[21:30-21:45] Part 4: what follows.</a:t>
+            </a:r>
+          </a:p>
+        </p:txBody>
+      </p:sp>
+      <p:sp>
+        <p:nvSpPr>
+          <p:cNvPr id="4" name="Slide Number Placeholder 3"/>
+          <p:cNvSpPr>
+            <a:spLocks noGrp="1"/>
+          </p:cNvSpPr>
+          <p:nvPr>
+            <p:ph type="sldNum" idx="5" sz="quarter"/>
+          </p:nvPr>
+        </p:nvSpPr>
+        <p:spPr/>
+      </p:sp>
+    </p:spTree>
+  </p:cSld>
+  <p:clrMapOvr>
+    <a:masterClrMapping/>
+  </p:clrMapOvr>
+</p:notes>
+</file>
+
+<file path=ppt/notesSlides/notesSlide19.xml><?xml version="1.0" encoding="utf-8"?>
+<p:notes xmlns:a="http://schemas.openxmlformats.org/drawingml/2006/main" xmlns:p="http://schemas.openxmlformats.org/presentationml/2006/main" xmlns:r="http://schemas.openxmlformats.org/officeDocument/2006/relationships">
+  <p:cSld>
+    <p:spTree>
+      <p:nvGrpSpPr>
+        <p:cNvPr id="1" name=""/>
+        <p:cNvGrpSpPr/>
+        <p:nvPr/>
+      </p:nvGrpSpPr>
+      <p:grpSpPr>
+        <a:xfrm>
+          <a:off x="0" y="0"/>
+          <a:ext cx="0" cy="0"/>
+          <a:chOff x="0" y="0"/>
+          <a:chExt cx="0" cy="0"/>
+        </a:xfrm>
+      </p:grpSpPr>
+      <p:sp>
+        <p:nvSpPr>
+          <p:cNvPr id="2" name="Slide Image Placeholder 1"/>
+          <p:cNvSpPr>
+            <a:spLocks noGrp="1"/>
+          </p:cNvSpPr>
+          <p:nvPr>
+            <p:ph type="sldImg" idx="2"/>
+          </p:nvPr>
+        </p:nvSpPr>
+        <p:spPr/>
+      </p:sp>
+      <p:sp>
+        <p:nvSpPr>
+          <p:cNvPr id="3" name="Notes Placeholder 2"/>
+          <p:cNvSpPr>
+            <a:spLocks noGrp="1"/>
+          </p:cNvSpPr>
+          <p:nvPr>
+            <p:ph type="body" idx="3" sz="quarter"/>
+          </p:nvPr>
+        </p:nvSpPr>
+        <p:spPr/>
+        <p:txBody>
+          <a:bodyPr/>
+          <a:lstStyle/>
+          <a:p>
+            <a:r>
+              <a:t>[21:45-23:15] Limits: synthetic one-message clients, one shelf and date, a benign window, OpenRouter access with reasoning off, one wording, and the double coding of the conflict item is prepared but must be completed by two group members.</a:t>
             </a:r>
           </a:p>
         </p:txBody>
@@ -2695,7 +3116,147 @@
           <a:lstStyle/>
           <a:p>
             <a:r>
-              <a:t>Agenda.</a:t>
+              <a:t>[0:45-1:15] Four parts: motivation, design, results, implications and limits.</a:t>
+            </a:r>
+          </a:p>
+        </p:txBody>
+      </p:sp>
+      <p:sp>
+        <p:nvSpPr>
+          <p:cNvPr id="4" name="Slide Number Placeholder 3"/>
+          <p:cNvSpPr>
+            <a:spLocks noGrp="1"/>
+          </p:cNvSpPr>
+          <p:nvPr>
+            <p:ph type="sldNum" idx="5" sz="quarter"/>
+          </p:nvPr>
+        </p:nvSpPr>
+        <p:spPr/>
+      </p:sp>
+    </p:spTree>
+  </p:cSld>
+  <p:clrMapOvr>
+    <a:masterClrMapping/>
+  </p:clrMapOvr>
+</p:notes>
+</file>
+
+<file path=ppt/notesSlides/notesSlide20.xml><?xml version="1.0" encoding="utf-8"?>
+<p:notes xmlns:a="http://schemas.openxmlformats.org/drawingml/2006/main" xmlns:p="http://schemas.openxmlformats.org/presentationml/2006/main" xmlns:r="http://schemas.openxmlformats.org/officeDocument/2006/relationships">
+  <p:cSld>
+    <p:spTree>
+      <p:nvGrpSpPr>
+        <p:cNvPr id="1" name=""/>
+        <p:cNvGrpSpPr/>
+        <p:nvPr/>
+      </p:nvGrpSpPr>
+      <p:grpSpPr>
+        <a:xfrm>
+          <a:off x="0" y="0"/>
+          <a:ext cx="0" cy="0"/>
+          <a:chOff x="0" y="0"/>
+          <a:chExt cx="0" cy="0"/>
+        </a:xfrm>
+      </p:grpSpPr>
+      <p:sp>
+        <p:nvSpPr>
+          <p:cNvPr id="2" name="Slide Image Placeholder 1"/>
+          <p:cNvSpPr>
+            <a:spLocks noGrp="1"/>
+          </p:cNvSpPr>
+          <p:nvPr>
+            <p:ph type="sldImg" idx="2"/>
+          </p:nvPr>
+        </p:nvSpPr>
+        <p:spPr/>
+      </p:sp>
+      <p:sp>
+        <p:nvSpPr>
+          <p:cNvPr id="3" name="Notes Placeholder 2"/>
+          <p:cNvSpPr>
+            <a:spLocks noGrp="1"/>
+          </p:cNvSpPr>
+          <p:nvPr>
+            <p:ph type="body" idx="3" sz="quarter"/>
+          </p:nvPr>
+        </p:nvSpPr>
+        <p:spPr/>
+        <p:txBody>
+          <a:bodyPr/>
+          <a:lstStyle/>
+          <a:p>
+            <a:r>
+              <a:t>[23:15-24:45] Three takeaways: tailoring is one-dimensional; a rule in the prompt is not a control, so enforce suitability in code; audit with repeated queries.</a:t>
+            </a:r>
+          </a:p>
+        </p:txBody>
+      </p:sp>
+      <p:sp>
+        <p:nvSpPr>
+          <p:cNvPr id="4" name="Slide Number Placeholder 3"/>
+          <p:cNvSpPr>
+            <a:spLocks noGrp="1"/>
+          </p:cNvSpPr>
+          <p:nvPr>
+            <p:ph type="sldNum" idx="5" sz="quarter"/>
+          </p:nvPr>
+        </p:nvSpPr>
+        <p:spPr/>
+      </p:sp>
+    </p:spTree>
+  </p:cSld>
+  <p:clrMapOvr>
+    <a:masterClrMapping/>
+  </p:clrMapOvr>
+</p:notes>
+</file>
+
+<file path=ppt/notesSlides/notesSlide21.xml><?xml version="1.0" encoding="utf-8"?>
+<p:notes xmlns:a="http://schemas.openxmlformats.org/drawingml/2006/main" xmlns:p="http://schemas.openxmlformats.org/presentationml/2006/main" xmlns:r="http://schemas.openxmlformats.org/officeDocument/2006/relationships">
+  <p:cSld>
+    <p:spTree>
+      <p:nvGrpSpPr>
+        <p:cNvPr id="1" name=""/>
+        <p:cNvGrpSpPr/>
+        <p:nvPr/>
+      </p:nvGrpSpPr>
+      <p:grpSpPr>
+        <a:xfrm>
+          <a:off x="0" y="0"/>
+          <a:ext cx="0" cy="0"/>
+          <a:chOff x="0" y="0"/>
+          <a:chExt cx="0" cy="0"/>
+        </a:xfrm>
+      </p:grpSpPr>
+      <p:sp>
+        <p:nvSpPr>
+          <p:cNvPr id="2" name="Slide Image Placeholder 1"/>
+          <p:cNvSpPr>
+            <a:spLocks noGrp="1"/>
+          </p:cNvSpPr>
+          <p:nvPr>
+            <p:ph type="sldImg" idx="2"/>
+          </p:nvPr>
+        </p:nvSpPr>
+        <p:spPr/>
+      </p:sp>
+      <p:sp>
+        <p:nvSpPr>
+          <p:cNvPr id="3" name="Notes Placeholder 2"/>
+          <p:cNvSpPr>
+            <a:spLocks noGrp="1"/>
+          </p:cNvSpPr>
+          <p:nvPr>
+            <p:ph type="body" idx="3" sz="quarter"/>
+          </p:nvPr>
+        </p:nvSpPr>
+        <p:spPr/>
+        <p:txBody>
+          <a:bodyPr/>
+          <a:lstStyle/>
+          <a:p>
+            <a:r>
+              <a:t>[24:45-25:00] Thank you. Five minutes for questions.</a:t>
             </a:r>
           </a:p>
         </p:txBody>
@@ -2765,7 +3326,7 @@
           <a:lstStyle/>
           <a:p>
             <a:r>
-              <a:t>A licensed distributor classifies the client C1-C5 and the product R1-R5 and may only sell products at or below the client's class. A general-purpose model has no such duty.</a:t>
+              <a:t>[1:30-3:00] A licensed distributor must classify the client C1-C5 and the product R1-R5 and may only sell at or below the client's class. A general-purpose chatbot has no such duty. Of the course's four dimensions - feasibility, suitability, fairness, performance - our primary focus is suitability; feasibility and performance are secondary, and fairness is excluded by design.</a:t>
             </a:r>
           </a:p>
         </p:txBody>
@@ -2835,7 +3396,7 @@
           <a:lstStyle/>
           <a:p>
             <a:r>
-              <a:t>RQ1-RQ5 and hypotheses H1-H7 are pre-specified in research_design.md.</a:t>
+              <a:t>[3:00-4:15] Five questions and seven hypotheses, all fixed before any model was queried. Point to H4: risk tolerance should dominate, and H5: the protocol should cut breaches.</a:t>
             </a:r>
           </a:p>
         </p:txBody>
@@ -2905,7 +3466,7 @@
           <a:lstStyle/>
           <a:p>
             <a:r>
-              <a:t>Repeated-measures design: 200 unique investors; condition and model vary within investor.</a:t>
+              <a:t>[4:30-6:00] 200 synthetic investors, one per cell of 5 horizons x 5 risk classes x 8 age bands, so the attributes are uncorrelated. Every investor goes to every model under both prompts: 1,200 main replies, plus repeats and single-attribute probes, 2,508 calls in total, all answered.</a:t>
             </a:r>
           </a:p>
         </p:txBody>
@@ -2975,7 +3536,7 @@
           <a:lstStyle/>
           <a:p>
             <a:r>
-              <a:t>Every class is defined on the same criteria; the class code is never shown to the model.</a:t>
+              <a:t>[6:00-7:15] Each profile covers the know-your-client items: age, income, goal, horizon, liquidity, experience, amount and risk tolerance. Show the example: a 21-year-old student with very high risk tolerance but a 9-month horizon - a built-in conflict.</a:t>
             </a:r>
           </a:p>
         </p:txBody>
@@ -3045,7 +3606,7 @@
           <a:lstStyle/>
           <a:p>
             <a:r>
-              <a:t>Identity checked against two public records per fund. Product risk ratings from Eastmoney (Tiantian Fund), 23 Oct 2026, because the course API has no rating field; adjusted NAV history from the course API (fuyao).</a:t>
+              <a:t>[7:15-8:30] 23 real funds, verified against public records; ratings from Eastmoney because the course API has no rating field. No R5 fund, so only C1-C3 clients can break the rating rule.</a:t>
             </a:r>
           </a:p>
         </p:txBody>
@@ -3115,7 +3676,7 @@
           <a:lstStyle/>
           <a:p>
             <a:r>
-              <a:t>BASE is an exact prefix of SUIT, checked by an automated test.</a:t>
+              <a:t>[8:30-9:45] BASE is the adviser prompt with the rated menu; SUIT adds a four-step suitability protocol. BASE is an exact prefix of SUIT, so the protocol is the only difference.</a:t>
             </a:r>
           </a:p>
         </p:txBody>
@@ -3185,7 +3746,7 @@
           <a:lstStyle/>
           <a:p>
             <a:r>
-              <a:t>Effect sizes lead; p-values are Holm-adjusted.</a:t>
+              <a:t>[9:45-11:00] Every reply is scored mechanically: feasibility, rating breach, horizon cap, lock-up, loss tolerance against five years of NAV data, reliability, and - added after the main analysis - Sharpe, Calmar, benchmarks and fees. Effect sizes lead; p-values are Holm-adjusted.</a:t>
             </a:r>
           </a:p>
         </p:txBody>
@@ -13267,7 +13828,7 @@
                 </a:solidFill>
                 <a:latin typeface="Calibri"/>
               </a:rPr>
-              <a:t>17</a:t>
+              <a:t>18</a:t>
             </a:r>
           </a:p>
         </p:txBody>
@@ -13625,7 +14186,7 @@
                 </a:solidFill>
                 <a:latin typeface="Calibri"/>
               </a:rPr>
-              <a:t>18</a:t>
+              <a:t>19</a:t>
             </a:r>
           </a:p>
         </p:txBody>
@@ -14417,7 +14978,7 @@
                 </a:solidFill>
                 <a:latin typeface="Calibri"/>
               </a:rPr>
-              <a:t>Conflict acknowledgement awaits manual validation (two coders, kappa).</a:t>
+              <a:t>Conflict item: two-coder sheets for all 1,199 replies prepared; coding and kappa pending.</a:t>
             </a:r>
           </a:p>
         </p:txBody>
@@ -14775,7 +15336,7 @@
                 </a:solidFill>
                 <a:latin typeface="Calibri"/>
               </a:rPr>
-              <a:t>19</a:t>
+              <a:t>20</a:t>
             </a:r>
           </a:p>
         </p:txBody>
@@ -16535,6 +17096,780 @@
           </a:p>
         </p:txBody>
       </p:sp>
+    </p:spTree>
+  </p:cSld>
+  <p:clrMapOvr>
+    <a:masterClrMapping/>
+  </p:clrMapOvr>
+</p:sld>
+</file>
+
+<file path=ppt/slides/slide21.xml><?xml version="1.0" encoding="utf-8"?>
+<p:sld xmlns:a="http://schemas.openxmlformats.org/drawingml/2006/main" xmlns:p="http://schemas.openxmlformats.org/presentationml/2006/main" xmlns:r="http://schemas.openxmlformats.org/officeDocument/2006/relationships">
+  <p:cSld>
+    <p:spTree>
+      <p:nvGrpSpPr>
+        <p:cNvPr id="1" name=""/>
+        <p:cNvGrpSpPr/>
+        <p:nvPr/>
+      </p:nvGrpSpPr>
+      <p:grpSpPr/>
+      <p:sp>
+        <p:nvSpPr>
+          <p:cNvPr id="2" name="Rectangle 1"/>
+          <p:cNvSpPr/>
+          <p:nvPr/>
+        </p:nvSpPr>
+        <p:spPr>
+          <a:xfrm>
+            <a:off x="502920" y="0"/>
+            <a:ext cx="109728" cy="530352"/>
+          </a:xfrm>
+          <a:prstGeom prst="rect">
+            <a:avLst/>
+          </a:prstGeom>
+          <a:solidFill>
+            <a:srgbClr val="BE4D4C"/>
+          </a:solidFill>
+          <a:ln>
+            <a:noFill/>
+          </a:ln>
+          <a:effectLst/>
+        </p:spPr>
+        <p:style>
+          <a:lnRef idx="1">
+            <a:schemeClr val="accent1"/>
+          </a:lnRef>
+          <a:fillRef idx="3">
+            <a:schemeClr val="accent1"/>
+          </a:fillRef>
+          <a:effectRef idx="2">
+            <a:schemeClr val="accent1"/>
+          </a:effectRef>
+          <a:fontRef idx="minor">
+            <a:schemeClr val="lt1"/>
+          </a:fontRef>
+        </p:style>
+        <p:txBody>
+          <a:bodyPr rtlCol="0" anchor="ctr"/>
+          <a:lstStyle/>
+          <a:p>
+            <a:pPr algn="ctr"/>
+          </a:p>
+        </p:txBody>
+      </p:sp>
+      <p:sp>
+        <p:nvSpPr>
+          <p:cNvPr id="3" name="Rectangle 2"/>
+          <p:cNvSpPr/>
+          <p:nvPr/>
+        </p:nvSpPr>
+        <p:spPr>
+          <a:xfrm>
+            <a:off x="658368" y="237744"/>
+            <a:ext cx="109728" cy="292608"/>
+          </a:xfrm>
+          <a:prstGeom prst="rect">
+            <a:avLst/>
+          </a:prstGeom>
+          <a:solidFill>
+            <a:srgbClr val="BAD0E4"/>
+          </a:solidFill>
+          <a:ln>
+            <a:noFill/>
+          </a:ln>
+          <a:effectLst/>
+        </p:spPr>
+        <p:style>
+          <a:lnRef idx="1">
+            <a:schemeClr val="accent1"/>
+          </a:lnRef>
+          <a:fillRef idx="3">
+            <a:schemeClr val="accent1"/>
+          </a:fillRef>
+          <a:effectRef idx="2">
+            <a:schemeClr val="accent1"/>
+          </a:effectRef>
+          <a:fontRef idx="minor">
+            <a:schemeClr val="lt1"/>
+          </a:fontRef>
+        </p:style>
+        <p:txBody>
+          <a:bodyPr rtlCol="0" anchor="ctr"/>
+          <a:lstStyle/>
+          <a:p>
+            <a:pPr algn="ctr"/>
+          </a:p>
+        </p:txBody>
+      </p:sp>
+      <p:sp>
+        <p:nvSpPr>
+          <p:cNvPr id="4" name="TextBox 3"/>
+          <p:cNvSpPr txBox="1"/>
+          <p:nvPr/>
+        </p:nvSpPr>
+        <p:spPr>
+          <a:xfrm>
+            <a:off x="960120" y="118872"/>
+            <a:ext cx="7315200" cy="219456"/>
+          </a:xfrm>
+          <a:prstGeom prst="rect">
+            <a:avLst/>
+          </a:prstGeom>
+          <a:noFill/>
+        </p:spPr>
+        <p:txBody>
+          <a:bodyPr wrap="square" lIns="18288" rIns="18288" tIns="18288" bIns="18288" anchor="t">
+            <a:spAutoFit/>
+          </a:bodyPr>
+          <a:lstStyle/>
+          <a:p>
+            <a:pPr algn="l"/>
+            <a:r>
+              <a:rPr sz="950" b="1">
+                <a:solidFill>
+                  <a:srgbClr val="BE4D4C"/>
+                </a:solidFill>
+                <a:latin typeface="Calibri"/>
+              </a:rPr>
+              <a:t>PERFORMANCE AND BENCHMARKS (9.7)</a:t>
+            </a:r>
+          </a:p>
+        </p:txBody>
+      </p:sp>
+      <p:sp>
+        <p:nvSpPr>
+          <p:cNvPr id="5" name="TextBox 4"/>
+          <p:cNvSpPr txBox="1"/>
+          <p:nvPr/>
+        </p:nvSpPr>
+        <p:spPr>
+          <a:xfrm>
+            <a:off x="960120" y="329184"/>
+            <a:ext cx="7863840" cy="603504"/>
+          </a:xfrm>
+          <a:prstGeom prst="rect">
+            <a:avLst/>
+          </a:prstGeom>
+          <a:noFill/>
+        </p:spPr>
+        <p:txBody>
+          <a:bodyPr wrap="square" lIns="18288" rIns="18288" tIns="18288" bIns="18288" anchor="t">
+            <a:spAutoFit/>
+          </a:bodyPr>
+          <a:lstStyle/>
+          <a:p>
+            <a:pPr algn="l"/>
+            <a:r>
+              <a:rPr sz="2200" b="1">
+                <a:solidFill>
+                  <a:srgbClr val="365B7E"/>
+                </a:solidFill>
+                <a:latin typeface="Calibri"/>
+              </a:rPr>
+              <a:t>Good risk-adjusted returns, partly from breaking the rule</a:t>
+            </a:r>
+          </a:p>
+        </p:txBody>
+      </p:sp>
+      <p:pic>
+        <p:nvPicPr>
+          <p:cNvPr id="6" name="Picture 5" descr="image.png"/>
+          <p:cNvPicPr>
+            <a:picLocks noChangeAspect="1"/>
+          </p:cNvPicPr>
+          <p:nvPr/>
+        </p:nvPicPr>
+        <p:blipFill>
+          <a:blip r:embed="rId2"/>
+          <a:stretch>
+            <a:fillRect/>
+          </a:stretch>
+        </p:blipFill>
+        <p:spPr>
+          <a:xfrm>
+            <a:off x="8988552" y="82296"/>
+            <a:ext cx="2697480" cy="592543"/>
+          </a:xfrm>
+          <a:prstGeom prst="rect">
+            <a:avLst/>
+          </a:prstGeom>
+        </p:spPr>
+      </p:pic>
+      <p:sp>
+        <p:nvSpPr>
+          <p:cNvPr id="7" name="Rectangle 6"/>
+          <p:cNvSpPr/>
+          <p:nvPr/>
+        </p:nvSpPr>
+        <p:spPr>
+          <a:xfrm>
+            <a:off x="502920" y="1097280"/>
+            <a:ext cx="11183112" cy="10972"/>
+          </a:xfrm>
+          <a:prstGeom prst="rect">
+            <a:avLst/>
+          </a:prstGeom>
+          <a:solidFill>
+            <a:srgbClr val="BAD0E4"/>
+          </a:solidFill>
+          <a:ln>
+            <a:noFill/>
+          </a:ln>
+          <a:effectLst/>
+        </p:spPr>
+        <p:style>
+          <a:lnRef idx="1">
+            <a:schemeClr val="accent1"/>
+          </a:lnRef>
+          <a:fillRef idx="3">
+            <a:schemeClr val="accent1"/>
+          </a:fillRef>
+          <a:effectRef idx="2">
+            <a:schemeClr val="accent1"/>
+          </a:effectRef>
+          <a:fontRef idx="minor">
+            <a:schemeClr val="lt1"/>
+          </a:fontRef>
+        </p:style>
+        <p:txBody>
+          <a:bodyPr rtlCol="0" anchor="ctr"/>
+          <a:lstStyle/>
+          <a:p>
+            <a:pPr algn="ctr"/>
+          </a:p>
+        </p:txBody>
+      </p:sp>
+      <p:sp>
+        <p:nvSpPr>
+          <p:cNvPr id="8" name="Rectangle 7"/>
+          <p:cNvSpPr/>
+          <p:nvPr/>
+        </p:nvSpPr>
+        <p:spPr>
+          <a:xfrm>
+            <a:off x="502920" y="6355080"/>
+            <a:ext cx="11183112" cy="10972"/>
+          </a:xfrm>
+          <a:prstGeom prst="rect">
+            <a:avLst/>
+          </a:prstGeom>
+          <a:solidFill>
+            <a:srgbClr val="DDE4EB"/>
+          </a:solidFill>
+          <a:ln>
+            <a:noFill/>
+          </a:ln>
+          <a:effectLst/>
+        </p:spPr>
+        <p:style>
+          <a:lnRef idx="1">
+            <a:schemeClr val="accent1"/>
+          </a:lnRef>
+          <a:fillRef idx="3">
+            <a:schemeClr val="accent1"/>
+          </a:fillRef>
+          <a:effectRef idx="2">
+            <a:schemeClr val="accent1"/>
+          </a:effectRef>
+          <a:fontRef idx="minor">
+            <a:schemeClr val="lt1"/>
+          </a:fontRef>
+        </p:style>
+        <p:txBody>
+          <a:bodyPr rtlCol="0" anchor="ctr"/>
+          <a:lstStyle/>
+          <a:p>
+            <a:pPr algn="ctr"/>
+          </a:p>
+        </p:txBody>
+      </p:sp>
+      <p:sp>
+        <p:nvSpPr>
+          <p:cNvPr id="9" name="TextBox 8"/>
+          <p:cNvSpPr txBox="1"/>
+          <p:nvPr/>
+        </p:nvSpPr>
+        <p:spPr>
+          <a:xfrm>
+            <a:off x="502920" y="6419088"/>
+            <a:ext cx="7863840" cy="237744"/>
+          </a:xfrm>
+          <a:prstGeom prst="rect">
+            <a:avLst/>
+          </a:prstGeom>
+          <a:noFill/>
+        </p:spPr>
+        <p:txBody>
+          <a:bodyPr wrap="square" lIns="18288" rIns="18288" tIns="18288" bIns="18288" anchor="t">
+            <a:spAutoFit/>
+          </a:bodyPr>
+          <a:lstStyle/>
+          <a:p>
+            <a:pPr algn="l"/>
+            <a:r>
+              <a:rPr sz="850" b="0">
+                <a:solidFill>
+                  <a:srgbClr val="7F8C99"/>
+                </a:solidFill>
+                <a:latin typeface="Calibri"/>
+              </a:rPr>
+              <a:t>Who Gets What? Auditing LLM Mutual Fund Advice</a:t>
+            </a:r>
+          </a:p>
+        </p:txBody>
+      </p:sp>
+      <p:sp>
+        <p:nvSpPr>
+          <p:cNvPr id="10" name="TextBox 9"/>
+          <p:cNvSpPr txBox="1"/>
+          <p:nvPr/>
+        </p:nvSpPr>
+        <p:spPr>
+          <a:xfrm>
+            <a:off x="10561320" y="6400800"/>
+            <a:ext cx="1124712" cy="256032"/>
+          </a:xfrm>
+          <a:prstGeom prst="rect">
+            <a:avLst/>
+          </a:prstGeom>
+          <a:noFill/>
+        </p:spPr>
+        <p:txBody>
+          <a:bodyPr wrap="square" lIns="18288" rIns="18288" tIns="18288" bIns="18288" anchor="t">
+            <a:spAutoFit/>
+          </a:bodyPr>
+          <a:lstStyle/>
+          <a:p>
+            <a:pPr algn="r"/>
+            <a:r>
+              <a:rPr sz="1050" b="1">
+                <a:solidFill>
+                  <a:srgbClr val="365B7E"/>
+                </a:solidFill>
+                <a:latin typeface="Calibri"/>
+              </a:rPr>
+              <a:t>17</a:t>
+            </a:r>
+          </a:p>
+        </p:txBody>
+      </p:sp>
+      <p:sp>
+        <p:nvSpPr>
+          <p:cNvPr id="12" name="Rectangle 11"/>
+          <p:cNvSpPr/>
+          <p:nvPr/>
+        </p:nvSpPr>
+        <p:spPr>
+          <a:xfrm>
+            <a:off x="7726679" y="1371600"/>
+            <a:ext cx="3959352" cy="4754880"/>
+          </a:xfrm>
+          <a:prstGeom prst="rect">
+            <a:avLst/>
+          </a:prstGeom>
+          <a:solidFill>
+            <a:srgbClr val="F2F6FA"/>
+          </a:solidFill>
+          <a:ln>
+            <a:noFill/>
+          </a:ln>
+          <a:effectLst/>
+        </p:spPr>
+        <p:style>
+          <a:lnRef idx="1">
+            <a:schemeClr val="accent1"/>
+          </a:lnRef>
+          <a:fillRef idx="3">
+            <a:schemeClr val="accent1"/>
+          </a:fillRef>
+          <a:effectRef idx="2">
+            <a:schemeClr val="accent1"/>
+          </a:effectRef>
+          <a:fontRef idx="minor">
+            <a:schemeClr val="lt1"/>
+          </a:fontRef>
+        </p:style>
+        <p:txBody>
+          <a:bodyPr rtlCol="0" anchor="ctr"/>
+          <a:lstStyle/>
+          <a:p>
+            <a:pPr algn="ctr"/>
+          </a:p>
+        </p:txBody>
+      </p:sp>
+      <p:sp>
+        <p:nvSpPr>
+          <p:cNvPr id="13" name="Rectangle 12"/>
+          <p:cNvSpPr/>
+          <p:nvPr/>
+        </p:nvSpPr>
+        <p:spPr>
+          <a:xfrm>
+            <a:off x="7726679" y="1371600"/>
+            <a:ext cx="54864" cy="4754880"/>
+          </a:xfrm>
+          <a:prstGeom prst="rect">
+            <a:avLst/>
+          </a:prstGeom>
+          <a:solidFill>
+            <a:srgbClr val="BE4D4C"/>
+          </a:solidFill>
+          <a:ln>
+            <a:noFill/>
+          </a:ln>
+          <a:effectLst/>
+        </p:spPr>
+        <p:style>
+          <a:lnRef idx="1">
+            <a:schemeClr val="accent1"/>
+          </a:lnRef>
+          <a:fillRef idx="3">
+            <a:schemeClr val="accent1"/>
+          </a:fillRef>
+          <a:effectRef idx="2">
+            <a:schemeClr val="accent1"/>
+          </a:effectRef>
+          <a:fontRef idx="minor">
+            <a:schemeClr val="lt1"/>
+          </a:fontRef>
+        </p:style>
+        <p:txBody>
+          <a:bodyPr rtlCol="0" anchor="ctr"/>
+          <a:lstStyle/>
+          <a:p>
+            <a:pPr algn="ctr"/>
+          </a:p>
+        </p:txBody>
+      </p:sp>
+      <p:sp>
+        <p:nvSpPr>
+          <p:cNvPr id="14" name="TextBox 13"/>
+          <p:cNvSpPr txBox="1"/>
+          <p:nvPr/>
+        </p:nvSpPr>
+        <p:spPr>
+          <a:xfrm>
+            <a:off x="7955279" y="1481328"/>
+            <a:ext cx="3593592" cy="457200"/>
+          </a:xfrm>
+          <a:prstGeom prst="rect">
+            <a:avLst/>
+          </a:prstGeom>
+          <a:noFill/>
+        </p:spPr>
+        <p:txBody>
+          <a:bodyPr wrap="square" lIns="18288" rIns="18288" tIns="18288" bIns="18288" anchor="t">
+            <a:spAutoFit/>
+          </a:bodyPr>
+          <a:lstStyle/>
+          <a:p>
+            <a:pPr algn="l"/>
+            <a:r>
+              <a:rPr sz="2000" b="1">
+                <a:solidFill>
+                  <a:srgbClr val="365B7E"/>
+                </a:solidFill>
+                <a:latin typeface="Calibri"/>
+              </a:rPr>
+              <a:t>74-99%</a:t>
+            </a:r>
+          </a:p>
+        </p:txBody>
+      </p:sp>
+      <p:sp>
+        <p:nvSpPr>
+          <p:cNvPr id="15" name="TextBox 14"/>
+          <p:cNvSpPr txBox="1"/>
+          <p:nvPr/>
+        </p:nvSpPr>
+        <p:spPr>
+          <a:xfrm>
+            <a:off x="7955279" y="1938528"/>
+            <a:ext cx="3593592" cy="548640"/>
+          </a:xfrm>
+          <a:prstGeom prst="rect">
+            <a:avLst/>
+          </a:prstGeom>
+          <a:noFill/>
+        </p:spPr>
+        <p:txBody>
+          <a:bodyPr wrap="square" lIns="18288" rIns="18288" tIns="18288" bIns="18288" anchor="t">
+            <a:spAutoFit/>
+          </a:bodyPr>
+          <a:lstStyle/>
+          <a:p>
+            <a:pPr algn="l"/>
+            <a:r>
+              <a:rPr sz="1050" b="0">
+                <a:solidFill>
+                  <a:srgbClr val="4A4A4A"/>
+                </a:solidFill>
+                <a:latin typeface="Calibri"/>
+              </a:rPr>
+              <a:t>of AI portfolios for C2-C5 investors beat a 60/40 mix on the Sharpe ratio (60/40: 1.67% a year)</a:t>
+            </a:r>
+          </a:p>
+        </p:txBody>
+      </p:sp>
+      <p:sp>
+        <p:nvSpPr>
+          <p:cNvPr id="16" name="TextBox 15"/>
+          <p:cNvSpPr txBox="1"/>
+          <p:nvPr/>
+        </p:nvSpPr>
+        <p:spPr>
+          <a:xfrm>
+            <a:off x="7955279" y="2670048"/>
+            <a:ext cx="3593592" cy="457200"/>
+          </a:xfrm>
+          <a:prstGeom prst="rect">
+            <a:avLst/>
+          </a:prstGeom>
+          <a:noFill/>
+        </p:spPr>
+        <p:txBody>
+          <a:bodyPr wrap="square" lIns="18288" rIns="18288" tIns="18288" bIns="18288" anchor="t">
+            <a:spAutoFit/>
+          </a:bodyPr>
+          <a:lstStyle/>
+          <a:p>
+            <a:pPr algn="l"/>
+            <a:r>
+              <a:rPr sz="2000" b="1">
+                <a:solidFill>
+                  <a:srgbClr val="365B7E"/>
+                </a:solidFill>
+                <a:latin typeface="Calibri"/>
+              </a:rPr>
+              <a:t>76-78%</a:t>
+            </a:r>
+          </a:p>
+        </p:txBody>
+      </p:sp>
+      <p:sp>
+        <p:nvSpPr>
+          <p:cNvPr id="17" name="TextBox 16"/>
+          <p:cNvSpPr txBox="1"/>
+          <p:nvPr/>
+        </p:nvSpPr>
+        <p:spPr>
+          <a:xfrm>
+            <a:off x="7955279" y="3127248"/>
+            <a:ext cx="3593592" cy="548640"/>
+          </a:xfrm>
+          <a:prstGeom prst="rect">
+            <a:avLst/>
+          </a:prstGeom>
+          <a:noFill/>
+        </p:spPr>
+        <p:txBody>
+          <a:bodyPr wrap="square" lIns="18288" rIns="18288" tIns="18288" bIns="18288" anchor="t">
+            <a:spAutoFit/>
+          </a:bodyPr>
+          <a:lstStyle/>
+          <a:p>
+            <a:pPr algn="l"/>
+            <a:r>
+              <a:rPr sz="1050" b="0">
+                <a:solidFill>
+                  <a:srgbClr val="4A4A4A"/>
+                </a:solidFill>
+                <a:latin typeface="Calibri"/>
+              </a:rPr>
+              <a:t>of C4-C5 portfolios beat a rating-compliant model portfolio on Sharpe, helped by QDII funds</a:t>
+            </a:r>
+          </a:p>
+        </p:txBody>
+      </p:sp>
+      <p:sp>
+        <p:nvSpPr>
+          <p:cNvPr id="18" name="TextBox 17"/>
+          <p:cNvSpPr txBox="1"/>
+          <p:nvPr/>
+        </p:nvSpPr>
+        <p:spPr>
+          <a:xfrm>
+            <a:off x="7955279" y="3858768"/>
+            <a:ext cx="3593592" cy="457200"/>
+          </a:xfrm>
+          <a:prstGeom prst="rect">
+            <a:avLst/>
+          </a:prstGeom>
+          <a:noFill/>
+        </p:spPr>
+        <p:txBody>
+          <a:bodyPr wrap="square" lIns="18288" rIns="18288" tIns="18288" bIns="18288" anchor="t">
+            <a:spAutoFit/>
+          </a:bodyPr>
+          <a:lstStyle/>
+          <a:p>
+            <a:pPr algn="l"/>
+            <a:r>
+              <a:rPr sz="2000" b="1">
+                <a:solidFill>
+                  <a:srgbClr val="365B7E"/>
+                </a:solidFill>
+                <a:latin typeface="Calibri"/>
+              </a:rPr>
+              <a:t>2.09% vs 1.48%</a:t>
+            </a:r>
+          </a:p>
+        </p:txBody>
+      </p:sp>
+      <p:sp>
+        <p:nvSpPr>
+          <p:cNvPr id="19" name="TextBox 18"/>
+          <p:cNvSpPr txBox="1"/>
+          <p:nvPr/>
+        </p:nvSpPr>
+        <p:spPr>
+          <a:xfrm>
+            <a:off x="7955279" y="4315968"/>
+            <a:ext cx="3593592" cy="548640"/>
+          </a:xfrm>
+          <a:prstGeom prst="rect">
+            <a:avLst/>
+          </a:prstGeom>
+          <a:noFill/>
+        </p:spPr>
+        <p:txBody>
+          <a:bodyPr wrap="square" lIns="18288" rIns="18288" tIns="18288" bIns="18288" anchor="t">
+            <a:spAutoFit/>
+          </a:bodyPr>
+          <a:lstStyle/>
+          <a:p>
+            <a:pPr algn="l"/>
+            <a:r>
+              <a:rPr sz="1050" b="0">
+                <a:solidFill>
+                  <a:srgbClr val="4A4A4A"/>
+                </a:solidFill>
+                <a:latin typeface="Calibri"/>
+              </a:rPr>
+              <a:t>a year for C1 portfolios with vs without a non-permitted fund: the extra return breaks the rule</a:t>
+            </a:r>
+          </a:p>
+        </p:txBody>
+      </p:sp>
+      <p:sp>
+        <p:nvSpPr>
+          <p:cNvPr id="20" name="TextBox 19"/>
+          <p:cNvSpPr txBox="1"/>
+          <p:nvPr/>
+        </p:nvSpPr>
+        <p:spPr>
+          <a:xfrm>
+            <a:off x="7955279" y="5047488"/>
+            <a:ext cx="3593592" cy="457200"/>
+          </a:xfrm>
+          <a:prstGeom prst="rect">
+            <a:avLst/>
+          </a:prstGeom>
+          <a:noFill/>
+        </p:spPr>
+        <p:txBody>
+          <a:bodyPr wrap="square" lIns="18288" rIns="18288" tIns="18288" bIns="18288" anchor="t">
+            <a:spAutoFit/>
+          </a:bodyPr>
+          <a:lstStyle/>
+          <a:p>
+            <a:pPr algn="l"/>
+            <a:r>
+              <a:rPr sz="2000" b="1">
+                <a:solidFill>
+                  <a:srgbClr val="365B7E"/>
+                </a:solidFill>
+                <a:latin typeface="Calibri"/>
+              </a:rPr>
+              <a:t>0.29 pts</a:t>
+            </a:r>
+          </a:p>
+        </p:txBody>
+      </p:sp>
+      <p:sp>
+        <p:nvSpPr>
+          <p:cNvPr id="21" name="TextBox 20"/>
+          <p:cNvSpPr txBox="1"/>
+          <p:nvPr/>
+        </p:nvSpPr>
+        <p:spPr>
+          <a:xfrm>
+            <a:off x="7955279" y="5504688"/>
+            <a:ext cx="3593592" cy="548640"/>
+          </a:xfrm>
+          <a:prstGeom prst="rect">
+            <a:avLst/>
+          </a:prstGeom>
+          <a:noFill/>
+        </p:spPr>
+        <p:txBody>
+          <a:bodyPr wrap="square" lIns="18288" rIns="18288" tIns="18288" bIns="18288" anchor="t">
+            <a:spAutoFit/>
+          </a:bodyPr>
+          <a:lstStyle/>
+          <a:p>
+            <a:pPr algn="l"/>
+            <a:r>
+              <a:rPr sz="1050" b="0">
+                <a:solidFill>
+                  <a:srgbClr val="4A4A4A"/>
+                </a:solidFill>
+                <a:latin typeface="Calibri"/>
+              </a:rPr>
+              <a:t>at most, return lost to fees a year (standard rates); ongoing fees already in NAV</a:t>
+            </a:r>
+          </a:p>
+        </p:txBody>
+      </p:sp>
+      <p:pic>
+        <p:nvPicPr>
+          <p:cNvPr id="22" name="Picture 21" descr="F09_cumulative_growth_vs_benchmarks.png"/>
+          <p:cNvPicPr>
+            <a:picLocks noChangeAspect="1"/>
+          </p:cNvPicPr>
+          <p:nvPr/>
+        </p:nvPicPr>
+        <p:blipFill>
+          <a:blip r:embed="rId3"/>
+          <a:stretch>
+            <a:fillRect/>
+          </a:stretch>
+        </p:blipFill>
+        <p:spPr>
+          <a:xfrm>
+            <a:off x="1051560" y="1234440"/>
+            <a:ext cx="5995388" cy="2468880"/>
+          </a:xfrm>
+          <a:prstGeom prst="rect">
+            <a:avLst/>
+          </a:prstGeom>
+        </p:spPr>
+      </p:pic>
+      <p:pic>
+        <p:nvPicPr>
+          <p:cNvPr id="23" name="Picture 22" descr="F10_risk_return_vs_benchmarks.png"/>
+          <p:cNvPicPr>
+            <a:picLocks noChangeAspect="1"/>
+          </p:cNvPicPr>
+          <p:nvPr/>
+        </p:nvPicPr>
+        <p:blipFill>
+          <a:blip r:embed="rId4"/>
+          <a:stretch>
+            <a:fillRect/>
+          </a:stretch>
+        </p:blipFill>
+        <p:spPr>
+          <a:xfrm>
+            <a:off x="1051560" y="3794760"/>
+            <a:ext cx="5928498" cy="2468880"/>
+          </a:xfrm>
+          <a:prstGeom prst="rect">
+            <a:avLst/>
+          </a:prstGeom>
+        </p:spPr>
+      </p:pic>
     </p:spTree>
   </p:cSld>
   <p:clrMapOvr>

</xml_diff>

<commit_message>
Drop fairness from slides 1 and 11 and from Table 6; keep the one-line scope note in Section 2
Co-Authored-By: Claude Opus 5.5 <noreply@anthropic.com>
Claude-Session: https://claude.ai/code/session_01PCmAkTtoQHaefAhZET8xvj
</commit_message>
<xml_diff>
--- a/presentation/presentation.pptx
+++ b/presentation/presentation.pptx
@@ -7969,17 +7969,6 @@
               <a:rPr lang="en-US" dirty="0"/>
               <a:t> Reliability, model differences</a:t>
             </a:r>
-            <a:br>
-              <a:rPr lang="en-US" dirty="0"/>
-            </a:br>
-            <a:r>
-              <a:rPr lang="en-US" b="1" dirty="0"/>
-              <a:t>Not tested:</a:t>
-            </a:r>
-            <a:r>
-              <a:rPr lang="en-US" dirty="0"/>
-              <a:t> Fairness</a:t>
-            </a:r>
           </a:p>
         </p:txBody>
       </p:sp>
@@ -9892,46 +9881,6 @@
           <a:p>
             <a:pPr algn="ctr"/>
             <a:endParaRPr/>
-          </a:p>
-        </p:txBody>
-      </p:sp>
-      <p:sp>
-        <p:nvSpPr>
-          <p:cNvPr id="30" name="Fairness box"/>
-          <p:cNvSpPr/>
-          <p:nvPr/>
-        </p:nvSpPr>
-        <p:spPr>
-          <a:xfrm>
-            <a:off x="6199632" y="4892040"/>
-            <a:ext cx="5486400" cy="868680"/>
-          </a:xfrm>
-          <a:prstGeom prst="rect">
-            <a:avLst/>
-          </a:prstGeom>
-        </p:spPr>
-        <p:txBody>
-          <a:bodyPr wrap="square">
-            <a:spAutoFit/>
-          </a:bodyPr>
-          <a:lstStyle/>
-          <a:p>
-            <a:r>
-              <a:rPr lang="en-US" sz="1600" b="1" dirty="0"/>
-              <a:t>FAIRNESS</a:t>
-            </a:r>
-            <a:r>
-              <a:rPr lang="en-US" sz="1600" b="1" dirty="0" smtClean="0"/>
-              <a:t> (NOT TESTED)</a:t>
-            </a:r>
-            <a:endParaRPr lang="ru-RU" sz="1600" dirty="0" smtClean="0"/>
-          </a:p>
-          <a:p>
-            <a:r>
-              <a:rPr lang="en-US" sz="1400" dirty="0" smtClean="0"/>
-              <a:t>Profiles carry no gender, name or region, so the design has no demographic comparison; fairness is left for future work.</a:t>
-            </a:r>
-            <a:endParaRPr lang="en-US" sz="1400" dirty="0"/>
           </a:p>
         </p:txBody>
       </p:sp>

</xml_diff>

<commit_message>
Presentation: speaker assignment (5 speakers) in the notes
Co-Authored-By: Claude Opus 5.5 <noreply@anthropic.com>
Claude-Session: https://claude.ai/code/session_01PCmAkTtoQHaefAhZET8xvj
</commit_message>
<xml_diff>
--- a/presentation/presentation.pptx
+++ b/presentation/presentation.pptx
@@ -136,9 +136,9 @@
 </file>
 
 <file path=ppt/charts/chart1.xml><?xml version="1.0" encoding="utf-8"?>
-<c:chartSpace xmlns:c="http://schemas.openxmlformats.org/drawingml/2006/chart" xmlns:a="http://schemas.openxmlformats.org/drawingml/2006/main" xmlns:r="http://schemas.openxmlformats.org/officeDocument/2006/relationships">
+<c:chartSpace xmlns:c="http://schemas.openxmlformats.org/drawingml/2006/chart" xmlns:a="http://schemas.openxmlformats.org/drawingml/2006/main" xmlns:r="http://schemas.openxmlformats.org/officeDocument/2006/relationships" xmlns:c16r2="http://schemas.microsoft.com/office/drawing/2015/06/chart">
   <c:date1904 val="0"/>
-  <c:lang val="ru-RU"/>
+  <c:lang val="en-US"/>
   <c:roundedCorners val="1"/>
   <c:style val="2"/>
   <c:chart>
@@ -155,7 +155,6 @@
           </a:p>
         </c:rich>
       </c:tx>
-      <c:layout/>
       <c:overlay val="0"/>
     </c:title>
     <c:autoTitleDeleted val="0"/>
@@ -212,7 +211,6 @@
             <c:showLeaderLines val="0"/>
             <c:extLst>
               <c:ext xmlns:c15="http://schemas.microsoft.com/office/drawing/2012/chart" uri="{CE6537A1-D6FC-4f65-9D91-7224C49458BB}">
-                <c15:layout/>
                 <c15:showLeaderLines val="0"/>
               </c:ext>
             </c:extLst>
@@ -274,6 +272,9 @@
                 </c14:spPr>
               </c14:invertSolidFillFmt>
             </c:ext>
+            <c:ext xmlns:c16="http://schemas.microsoft.com/office/drawing/2014/chart" uri="{C3380CC4-5D6E-409C-BE32-E72D297353CC}">
+              <c16:uniqueId val="{00000000-BCA4-144B-88BC-A7D646EFF433}"/>
+            </c:ext>
           </c:extLst>
         </c:ser>
         <c:dLbls>
@@ -397,9 +398,9 @@
 </file>
 
 <file path=ppt/charts/chart2.xml><?xml version="1.0" encoding="utf-8"?>
-<c:chartSpace xmlns:c="http://schemas.openxmlformats.org/drawingml/2006/chart" xmlns:a="http://schemas.openxmlformats.org/drawingml/2006/main" xmlns:r="http://schemas.openxmlformats.org/officeDocument/2006/relationships">
+<c:chartSpace xmlns:c="http://schemas.openxmlformats.org/drawingml/2006/chart" xmlns:a="http://schemas.openxmlformats.org/drawingml/2006/main" xmlns:r="http://schemas.openxmlformats.org/officeDocument/2006/relationships" xmlns:c16r2="http://schemas.microsoft.com/office/drawing/2015/06/chart">
   <c:date1904 val="0"/>
-  <c:lang val="ru-RU"/>
+  <c:lang val="en-US"/>
   <c:roundedCorners val="1"/>
   <c:style val="2"/>
   <c:chart>
@@ -416,7 +417,6 @@
           </a:p>
         </c:rich>
       </c:tx>
-      <c:layout/>
       <c:overlay val="0"/>
     </c:title>
     <c:autoTitleDeleted val="0"/>
@@ -494,6 +494,11 @@
             </c:numRef>
           </c:val>
           <c:smooth val="0"/>
+          <c:extLst>
+            <c:ext xmlns:c16="http://schemas.microsoft.com/office/drawing/2014/chart" uri="{C3380CC4-5D6E-409C-BE32-E72D297353CC}">
+              <c16:uniqueId val="{00000000-6513-9C49-95D9-6BF19B5B3511}"/>
+            </c:ext>
+          </c:extLst>
         </c:ser>
         <c:ser>
           <c:idx val="1"/>
@@ -564,6 +569,11 @@
             </c:numRef>
           </c:val>
           <c:smooth val="0"/>
+          <c:extLst>
+            <c:ext xmlns:c16="http://schemas.microsoft.com/office/drawing/2014/chart" uri="{C3380CC4-5D6E-409C-BE32-E72D297353CC}">
+              <c16:uniqueId val="{00000001-6513-9C49-95D9-6BF19B5B3511}"/>
+            </c:ext>
+          </c:extLst>
         </c:ser>
         <c:ser>
           <c:idx val="2"/>
@@ -634,6 +644,11 @@
             </c:numRef>
           </c:val>
           <c:smooth val="0"/>
+          <c:extLst>
+            <c:ext xmlns:c16="http://schemas.microsoft.com/office/drawing/2014/chart" uri="{C3380CC4-5D6E-409C-BE32-E72D297353CC}">
+              <c16:uniqueId val="{00000002-6513-9C49-95D9-6BF19B5B3511}"/>
+            </c:ext>
+          </c:extLst>
         </c:ser>
         <c:ser>
           <c:idx val="3"/>
@@ -704,6 +719,11 @@
             </c:numRef>
           </c:val>
           <c:smooth val="0"/>
+          <c:extLst>
+            <c:ext xmlns:c16="http://schemas.microsoft.com/office/drawing/2014/chart" uri="{C3380CC4-5D6E-409C-BE32-E72D297353CC}">
+              <c16:uniqueId val="{00000003-6513-9C49-95D9-6BF19B5B3511}"/>
+            </c:ext>
+          </c:extLst>
         </c:ser>
         <c:ser>
           <c:idx val="4"/>
@@ -774,6 +794,11 @@
             </c:numRef>
           </c:val>
           <c:smooth val="0"/>
+          <c:extLst>
+            <c:ext xmlns:c16="http://schemas.microsoft.com/office/drawing/2014/chart" uri="{C3380CC4-5D6E-409C-BE32-E72D297353CC}">
+              <c16:uniqueId val="{00000004-6513-9C49-95D9-6BF19B5B3511}"/>
+            </c:ext>
+          </c:extLst>
         </c:ser>
         <c:ser>
           <c:idx val="5"/>
@@ -844,6 +869,11 @@
             </c:numRef>
           </c:val>
           <c:smooth val="0"/>
+          <c:extLst>
+            <c:ext xmlns:c16="http://schemas.microsoft.com/office/drawing/2014/chart" uri="{C3380CC4-5D6E-409C-BE32-E72D297353CC}">
+              <c16:uniqueId val="{00000005-6513-9C49-95D9-6BF19B5B3511}"/>
+            </c:ext>
+          </c:extLst>
         </c:ser>
         <c:dLbls>
           <c:showLegendKey val="0"/>
@@ -945,7 +975,6 @@
     </c:plotArea>
     <c:legend>
       <c:legendPos val="b"/>
-      <c:layout/>
       <c:overlay val="0"/>
       <c:txPr>
         <a:bodyPr/>
@@ -984,9 +1013,9 @@
 </file>
 
 <file path=ppt/charts/chart3.xml><?xml version="1.0" encoding="utf-8"?>
-<c:chartSpace xmlns:c="http://schemas.openxmlformats.org/drawingml/2006/chart" xmlns:a="http://schemas.openxmlformats.org/drawingml/2006/main" xmlns:r="http://schemas.openxmlformats.org/officeDocument/2006/relationships">
+<c:chartSpace xmlns:c="http://schemas.openxmlformats.org/drawingml/2006/chart" xmlns:a="http://schemas.openxmlformats.org/drawingml/2006/main" xmlns:r="http://schemas.openxmlformats.org/officeDocument/2006/relationships" xmlns:c16r2="http://schemas.microsoft.com/office/drawing/2015/06/chart">
   <c:date1904 val="0"/>
-  <c:lang val="ru-RU"/>
+  <c:lang val="en-US"/>
   <c:roundedCorners val="1"/>
   <c:style val="2"/>
   <c:chart>
@@ -1003,7 +1032,6 @@
           </a:p>
         </c:rich>
       </c:tx>
-      <c:layout/>
       <c:overlay val="0"/>
     </c:title>
     <c:autoTitleDeleted val="0"/>
@@ -1078,6 +1106,9 @@
                 </c14:spPr>
               </c14:invertSolidFillFmt>
             </c:ext>
+            <c:ext xmlns:c16="http://schemas.microsoft.com/office/drawing/2014/chart" uri="{C3380CC4-5D6E-409C-BE32-E72D297353CC}">
+              <c16:uniqueId val="{00000000-802F-D943-8CA9-5DFC304BABD2}"/>
+            </c:ext>
           </c:extLst>
         </c:ser>
         <c:ser>
@@ -1144,6 +1175,9 @@
                   </a:solidFill>
                 </c14:spPr>
               </c14:invertSolidFillFmt>
+            </c:ext>
+            <c:ext xmlns:c16="http://schemas.microsoft.com/office/drawing/2014/chart" uri="{C3380CC4-5D6E-409C-BE32-E72D297353CC}">
+              <c16:uniqueId val="{00000001-802F-D943-8CA9-5DFC304BABD2}"/>
             </c:ext>
           </c:extLst>
         </c:ser>
@@ -1212,6 +1246,9 @@
                 </c14:spPr>
               </c14:invertSolidFillFmt>
             </c:ext>
+            <c:ext xmlns:c16="http://schemas.microsoft.com/office/drawing/2014/chart" uri="{C3380CC4-5D6E-409C-BE32-E72D297353CC}">
+              <c16:uniqueId val="{00000002-802F-D943-8CA9-5DFC304BABD2}"/>
+            </c:ext>
           </c:extLst>
         </c:ser>
         <c:ser>
@@ -1278,6 +1315,9 @@
                   </a:solidFill>
                 </c14:spPr>
               </c14:invertSolidFillFmt>
+            </c:ext>
+            <c:ext xmlns:c16="http://schemas.microsoft.com/office/drawing/2014/chart" uri="{C3380CC4-5D6E-409C-BE32-E72D297353CC}">
+              <c16:uniqueId val="{00000003-802F-D943-8CA9-5DFC304BABD2}"/>
             </c:ext>
           </c:extLst>
         </c:ser>
@@ -1346,6 +1386,9 @@
                 </c14:spPr>
               </c14:invertSolidFillFmt>
             </c:ext>
+            <c:ext xmlns:c16="http://schemas.microsoft.com/office/drawing/2014/chart" uri="{C3380CC4-5D6E-409C-BE32-E72D297353CC}">
+              <c16:uniqueId val="{00000004-802F-D943-8CA9-5DFC304BABD2}"/>
+            </c:ext>
           </c:extLst>
         </c:ser>
         <c:ser>
@@ -1413,6 +1456,9 @@
                 </c14:spPr>
               </c14:invertSolidFillFmt>
             </c:ext>
+            <c:ext xmlns:c16="http://schemas.microsoft.com/office/drawing/2014/chart" uri="{C3380CC4-5D6E-409C-BE32-E72D297353CC}">
+              <c16:uniqueId val="{00000005-802F-D943-8CA9-5DFC304BABD2}"/>
+            </c:ext>
           </c:extLst>
         </c:ser>
         <c:dLbls>
@@ -1514,7 +1560,6 @@
     </c:plotArea>
     <c:legend>
       <c:legendPos val="b"/>
-      <c:layout/>
       <c:overlay val="0"/>
       <c:txPr>
         <a:bodyPr/>
@@ -1553,9 +1598,9 @@
 </file>
 
 <file path=ppt/charts/chart4.xml><?xml version="1.0" encoding="utf-8"?>
-<c:chartSpace xmlns:c="http://schemas.openxmlformats.org/drawingml/2006/chart" xmlns:a="http://schemas.openxmlformats.org/drawingml/2006/main" xmlns:r="http://schemas.openxmlformats.org/officeDocument/2006/relationships">
+<c:chartSpace xmlns:c="http://schemas.openxmlformats.org/drawingml/2006/chart" xmlns:a="http://schemas.openxmlformats.org/drawingml/2006/main" xmlns:r="http://schemas.openxmlformats.org/officeDocument/2006/relationships" xmlns:c16r2="http://schemas.microsoft.com/office/drawing/2015/06/chart">
   <c:date1904 val="0"/>
-  <c:lang val="ru-RU"/>
+  <c:lang val="en-US"/>
   <c:roundedCorners val="1"/>
   <c:style val="2"/>
   <c:chart>
@@ -1572,7 +1617,6 @@
           </a:p>
         </c:rich>
       </c:tx>
-      <c:layout/>
       <c:overlay val="0"/>
     </c:title>
     <c:autoTitleDeleted val="0"/>
@@ -1630,7 +1674,6 @@
             <c:showLeaderLines val="0"/>
             <c:extLst>
               <c:ext xmlns:c15="http://schemas.microsoft.com/office/drawing/2012/chart" uri="{CE6537A1-D6FC-4f65-9D91-7224C49458BB}">
-                <c15:layout/>
                 <c15:showLeaderLines val="0"/>
               </c:ext>
             </c:extLst>
@@ -1679,6 +1722,9 @@
                   </a:solidFill>
                 </c14:spPr>
               </c14:invertSolidFillFmt>
+            </c:ext>
+            <c:ext xmlns:c16="http://schemas.microsoft.com/office/drawing/2014/chart" uri="{C3380CC4-5D6E-409C-BE32-E72D297353CC}">
+              <c16:uniqueId val="{00000000-8C3A-E540-8AA3-9442A6830BD8}"/>
             </c:ext>
           </c:extLst>
         </c:ser>
@@ -1730,7 +1776,6 @@
             <c:showLeaderLines val="0"/>
             <c:extLst>
               <c:ext xmlns:c15="http://schemas.microsoft.com/office/drawing/2012/chart" uri="{CE6537A1-D6FC-4f65-9D91-7224C49458BB}">
-                <c15:layout/>
                 <c15:showLeaderLines val="0"/>
               </c:ext>
             </c:extLst>
@@ -1780,6 +1825,9 @@
                 </c14:spPr>
               </c14:invertSolidFillFmt>
             </c:ext>
+            <c:ext xmlns:c16="http://schemas.microsoft.com/office/drawing/2014/chart" uri="{C3380CC4-5D6E-409C-BE32-E72D297353CC}">
+              <c16:uniqueId val="{00000001-8C3A-E540-8AA3-9442A6830BD8}"/>
+            </c:ext>
           </c:extLst>
         </c:ser>
         <c:dLbls>
@@ -1881,7 +1929,6 @@
     </c:plotArea>
     <c:legend>
       <c:legendPos val="b"/>
-      <c:layout/>
       <c:overlay val="0"/>
       <c:txPr>
         <a:bodyPr/>
@@ -1920,9 +1967,9 @@
 </file>
 
 <file path=ppt/charts/chart5.xml><?xml version="1.0" encoding="utf-8"?>
-<c:chartSpace xmlns:c="http://schemas.openxmlformats.org/drawingml/2006/chart" xmlns:a="http://schemas.openxmlformats.org/drawingml/2006/main" xmlns:r="http://schemas.openxmlformats.org/officeDocument/2006/relationships">
+<c:chartSpace xmlns:c="http://schemas.openxmlformats.org/drawingml/2006/chart" xmlns:a="http://schemas.openxmlformats.org/drawingml/2006/main" xmlns:r="http://schemas.openxmlformats.org/officeDocument/2006/relationships" xmlns:c16r2="http://schemas.microsoft.com/office/drawing/2015/06/chart">
   <c:date1904 val="0"/>
-  <c:lang val="ru-RU"/>
+  <c:lang val="en-US"/>
   <c:roundedCorners val="1"/>
   <c:style val="2"/>
   <c:chart>
@@ -1939,7 +1986,6 @@
           </a:p>
         </c:rich>
       </c:tx>
-      <c:layout/>
       <c:overlay val="0"/>
     </c:title>
     <c:autoTitleDeleted val="0"/>
@@ -2032,6 +2078,9 @@
                 </c14:spPr>
               </c14:invertSolidFillFmt>
             </c:ext>
+            <c:ext xmlns:c16="http://schemas.microsoft.com/office/drawing/2014/chart" uri="{C3380CC4-5D6E-409C-BE32-E72D297353CC}">
+              <c16:uniqueId val="{00000000-61CB-974D-B053-67233647A77C}"/>
+            </c:ext>
           </c:extLst>
         </c:ser>
         <c:ser>
@@ -2117,6 +2166,9 @@
                 </c14:spPr>
               </c14:invertSolidFillFmt>
             </c:ext>
+            <c:ext xmlns:c16="http://schemas.microsoft.com/office/drawing/2014/chart" uri="{C3380CC4-5D6E-409C-BE32-E72D297353CC}">
+              <c16:uniqueId val="{00000001-61CB-974D-B053-67233647A77C}"/>
+            </c:ext>
           </c:extLst>
         </c:ser>
         <c:dLbls>
@@ -2218,7 +2270,6 @@
     </c:plotArea>
     <c:legend>
       <c:legendPos val="b"/>
-      <c:layout/>
       <c:overlay val="0"/>
       <c:txPr>
         <a:bodyPr/>
@@ -2338,7 +2389,7 @@
           <a:p>
             <a:fld id="{7FEBC446-EBC2-46BD-B860-DF8FFCEF87B7}" type="datetimeFigureOut">
               <a:rPr lang="zh-CN" altLang="en-US" smtClean="0"/>
-              <a:t>2026/10/24</a:t>
+              <a:t>2026/10/30</a:t>
             </a:fld>
             <a:endParaRPr lang="zh-CN" altLang="en-US"/>
           </a:p>
@@ -2650,7 +2701,7 @@
           <a:lstStyle/>
           <a:p>
             <a:r>
-              <a:t>[0:00-0:45] Title. We audited three Chinese chatbots as fund advisers: do they tailor advice to the client, is it suitable under China's rules, and does a suitability protocol in the prompt help?</a:t>
+              <a:t>SPEAKER 1. [0:00-0:45] Title. We audited three Chinese chatbots as fund advisers: do they tailor advice to the client, is it suitable under China's rules, and does a suitability protocol in the prompt help?</a:t>
             </a:r>
           </a:p>
         </p:txBody>
@@ -2725,7 +2776,7 @@
           <a:lstStyle/>
           <a:p>
             <a:r>
-              <a:t>[8:30-9:45] BASE is the adviser prompt with the rated menu; SUIT adds a four-step suitability protocol. BASE is an exact prefix of SUIT, so the protocol is the only difference.</a:t>
+              <a:t>SPEAKER 2. [8:30-9:45] BASE is the adviser prompt with the rated menu; SUIT adds a four-step suitability protocol. BASE is an exact prefix of SUIT, so the protocol is the only difference.</a:t>
             </a:r>
           </a:p>
         </p:txBody>
@@ -2800,7 +2851,7 @@
           <a:lstStyle/>
           <a:p>
             <a:r>
-              <a:t>[9:45-11:00] Every reply is scored mechanically: feasibility, rating breach, horizon cap, lock-up, loss tolerance against five years of NAV data, reliability, and - added after the main analysis - Sharpe, Calmar, benchmarks and fees. Effect sizes lead; p-values are Holm-adjusted.</a:t>
+              <a:t>SPEAKER 3. [9:45-11:00] Every reply is scored mechanically: feasibility, rating breach, horizon cap, lock-up, loss tolerance against five years of NAV data, reliability, and - added after the main analysis - Sharpe, Calmar, benchmarks and fees. Effect sizes lead; p-values are Holm-adjusted.</a:t>
             </a:r>
           </a:p>
         </p:txBody>
@@ -2875,7 +2926,7 @@
           <a:lstStyle/>
           <a:p>
             <a:r>
-              <a:t>[11:00-11:15] Part 3: results.</a:t>
+              <a:t>SPEAKER 3. [11:00-11:15] Part 3: results.</a:t>
             </a:r>
           </a:p>
         </p:txBody>
@@ -2950,7 +3001,7 @@
           <a:lstStyle/>
           <a:p>
             <a:r>
-              <a:t>[11:15-13:15] Risk tolerance drives the portfolio: partial eta squared 0.66-0.83. Horizon works as a switch below one year. Age barely matters, against life-cycle theory.</a:t>
+              <a:t>SPEAKER 3. [11:15-13:15] Risk tolerance drives the portfolio: partial eta squared 0.66-0.83. Horizon works as a switch below one year. Age barely matters, against life-cycle theory.</a:t>
             </a:r>
           </a:p>
         </p:txBody>
@@ -3025,7 +3076,7 @@
           <a:lstStyle/>
           <a:p>
             <a:r>
-              <a:t>[13:15-15:45] The key finding: although ratings are in the prompt, 82.5-85.8% of BASE replies to C1-C3 clients contain a fund above the ceiling, mostly bond funds for C1. Aggressive clients with 1-3 year horizons get about 78% equity against a 30% cap. Losses beyond the stated limit were rare, but the window was benign for bonds.</a:t>
+              <a:t>SPEAKER 3. [13:15-15:45] The key finding: although ratings are in the prompt, 82.5-85.8% of BASE replies to C1-C3 clients contain a fund above the ceiling, mostly bond funds for C1. Aggressive clients with 1-3 year horizons get about 78% equity against a 30% cap. Losses beyond the stated limit were rare, but the window was benign for bonds.</a:t>
             </a:r>
           </a:p>
         </p:txBody>
@@ -3100,7 +3151,7 @@
           <a:lstStyle/>
           <a:p>
             <a:r>
-              <a:t>[15:45-18:00] The protocol cuts rating breaches in every model, by 9.5, 11.1 and 24.5 points, and the models flag the conflict far more often. But compliance does not follow: many clients the model classified correctly still get a fund above their class. Double-coded, replies named the risk-horizon conflict in 81-100% of SUIT cases. Under SUIT the models differ; Kimi responds most.</a:t>
+              <a:t>SPEAKER 4. [15:45-18:00] The protocol cuts rating breaches in every model, by 9.5, 11.1 and 24.5 points, and the models flag the conflict far more often. But compliance does not follow: many clients the model classified correctly still get a fund above their class. Double-coded, replies named the risk-horizon conflict in 81-100% of SUIT cases. Under SUIT the models differ; Kimi responds most.</a:t>
             </a:r>
           </a:p>
         </p:txBody>
@@ -3175,7 +3226,7 @@
           <a:lstStyle/>
           <a:p>
             <a:r>
-              <a:t>[18:00-19:30] Same question three times: equity is stable, fund choices are not, and the breach verdict changes for up to 17.5% of clients. Probes: the stated horizon on its own moves equity only 1-4 points.</a:t>
+              <a:t>SPEAKER 4. [18:00-19:30] Same question three times: equity is stable, fund choices are not, and the breach verdict changes for up to 17.5% of clients. Probes: the stated horizon on its own moves equity only 1-4 points.</a:t>
             </a:r>
           </a:p>
         </p:txBody>
@@ -3250,7 +3301,7 @@
           <a:lstStyle/>
           <a:p>
             <a:r>
-              <a:t>[19:30-21:30] Performance over Nov 2021 - Sep 2026, a weak period for Chinese equities. Most portfolios beat a 60/40 mix on the Sharpe ratio, and aggressive clients' portfolios beat a rating-compliant model portfolio. For cautious clients the extra return came from non-permitted funds: performance and compliance pulled apart. Fees are negligible. The model portfolio is our stylised robo ladder, not a commercial robo record.</a:t>
+              <a:t>SPEAKER 5. [19:30-21:30] Performance over Nov 2021 - Sep 2026, a weak period for Chinese equities. Most portfolios beat a 60/40 mix on the Sharpe ratio, and aggressive clients' portfolios beat a rating-compliant model portfolio. For cautious clients the extra return came from non-permitted funds: performance and compliance pulled apart. Fees are negligible. The model portfolio is our stylised robo ladder, not a commercial robo record.</a:t>
             </a:r>
           </a:p>
         </p:txBody>
@@ -3325,7 +3376,7 @@
           <a:lstStyle/>
           <a:p>
             <a:r>
-              <a:t>[21:30-21:45] Part 4: what follows.</a:t>
+              <a:t>SPEAKER 5. [21:30-21:45] Part 4: what follows.</a:t>
             </a:r>
           </a:p>
         </p:txBody>
@@ -3400,7 +3451,7 @@
           <a:lstStyle/>
           <a:p>
             <a:r>
-              <a:t>[21:45-23:15] Limits: synthetic one-message clients, one shelf and date, a benign window, OpenRouter access with reasoning off, one wording. The conflict item was double-coded for every reply with kappa 0.95.</a:t>
+              <a:t>SPEAKER 5. [21:45-23:15] Limits: synthetic one-message clients, one shelf and date, a benign window, OpenRouter access with reasoning off, one wording. The conflict item was double-coded for every reply with kappa 0.95.</a:t>
             </a:r>
           </a:p>
         </p:txBody>
@@ -3475,7 +3526,7 @@
           <a:lstStyle/>
           <a:p>
             <a:r>
-              <a:t>[0:45-1:15] Four parts: motivation, design, results, implications and limits.</a:t>
+              <a:t>SPEAKER 1. [0:45-1:15] Four parts: motivation, design, results, implications and limits.</a:t>
             </a:r>
           </a:p>
         </p:txBody>
@@ -3550,7 +3601,7 @@
           <a:lstStyle/>
           <a:p>
             <a:r>
-              <a:t>[23:15-24:45] Three takeaways: tailoring is one-dimensional; a rule in the prompt is not a control, so enforce suitability in code; audit with repeated queries.</a:t>
+              <a:t>SPEAKER 5. [23:15-24:45] Three takeaways: tailoring is one-dimensional; a rule in the prompt is not a control, so enforce suitability in code; audit with repeated queries.</a:t>
             </a:r>
           </a:p>
         </p:txBody>
@@ -3625,7 +3676,7 @@
           <a:lstStyle/>
           <a:p>
             <a:r>
-              <a:t>[24:45-25:00] Thank you. Five minutes for questions.</a:t>
+              <a:t>SPEAKER 5. [24:45-25:00] Thank you. Five minutes for questions.</a:t>
             </a:r>
           </a:p>
         </p:txBody>
@@ -3700,7 +3751,7 @@
           <a:lstStyle/>
           <a:p>
             <a:r>
-              <a:t>[1:15-1:30] Part 1: why this needs an audit.</a:t>
+              <a:t>SPEAKER 1. [1:15-1:30] Part 1: why this needs an audit.</a:t>
             </a:r>
           </a:p>
         </p:txBody>
@@ -3775,7 +3826,7 @@
           <a:lstStyle/>
           <a:p>
             <a:r>
-              <a:t>[1:30-3:00] A licensed distributor must classify the client C1-C5 and the product R1-R5 and may only sell at or below the client's class. A general-purpose chatbot has no such duty. Of the course's four dimensions - feasibility, suitability, fairness, performance - our primary focus is suitability; feasibility and performance are secondary, and fairness is excluded by design.</a:t>
+              <a:t>SPEAKER 1. [1:30-3:00] A licensed distributor must classify the client C1-C5 and the product R1-R5 and may only sell at or below the client's class. A general-purpose chatbot has no such duty. Of the course's four dimensions - feasibility, suitability, fairness, performance - our primary focus is suitability; feasibility and performance are secondary, and fairness is excluded by design.</a:t>
             </a:r>
           </a:p>
         </p:txBody>
@@ -3850,7 +3901,7 @@
           <a:lstStyle/>
           <a:p>
             <a:r>
-              <a:t>[3:00-4:15] Five questions and seven hypotheses, all fixed before any model was queried. Point to H4: risk tolerance should dominate, and H5: the protocol should cut breaches.</a:t>
+              <a:t>SPEAKER 1. [3:00-4:15] Five questions and seven hypotheses, all fixed before any model was queried. Point to H4: risk tolerance should dominate, and H5: the protocol should cut breaches.</a:t>
             </a:r>
           </a:p>
         </p:txBody>
@@ -3925,7 +3976,7 @@
           <a:lstStyle/>
           <a:p>
             <a:r>
-              <a:t>[4:15-4:30] Part 2: how we built the experiment.</a:t>
+              <a:t>SPEAKER 2. [4:15-4:30] Part 2: how we built the experiment.</a:t>
             </a:r>
           </a:p>
         </p:txBody>
@@ -4000,7 +4051,7 @@
           <a:lstStyle/>
           <a:p>
             <a:r>
-              <a:t>[4:30-6:00] 200 synthetic investors, one per cell of 5 horizons x 5 risk classes x 8 age bands, so the attributes are uncorrelated. Every investor goes to every model under both prompts: 1,200 main replies, plus repeats and single-attribute probes, 2,508 calls in total, all answered.</a:t>
+              <a:t>SPEAKER 2. [4:30-6:00] 200 synthetic investors, one per cell of 5 horizons x 5 risk classes x 8 age bands, so the attributes are uncorrelated. Every investor goes to every model under both prompts: 1,200 main replies, plus repeats and single-attribute probes, 2,508 calls in total, all answered.</a:t>
             </a:r>
           </a:p>
         </p:txBody>
@@ -4075,7 +4126,7 @@
           <a:lstStyle/>
           <a:p>
             <a:r>
-              <a:t>[6:00-7:15] Each profile covers the know-your-client items: age, income, goal, horizon, liquidity, experience, amount and risk tolerance. Show the example: a 21-year-old student with very high risk tolerance but a 9-month horizon - a built-in conflict.</a:t>
+              <a:t>SPEAKER 2. [6:00-7:15] Each profile covers the know-your-client items: age, income, goal, horizon, liquidity, experience, amount and risk tolerance. Show the example: a 21-year-old student with very high risk tolerance but a 9-month horizon - a built-in conflict.</a:t>
             </a:r>
           </a:p>
         </p:txBody>
@@ -4150,7 +4201,7 @@
           <a:lstStyle/>
           <a:p>
             <a:r>
-              <a:t>[7:15-8:30] 23 real funds, verified against public records; ratings from Eastmoney because the course API has no rating field. No R5 fund, so only C1-C3 clients can break the rating rule.</a:t>
+              <a:t>SPEAKER 2. [7:15-8:30] 23 real funds, verified against public records; ratings from Eastmoney because the course API has no rating field. No R5 fund, so only C1-C3 clients can break the rating rule.</a:t>
             </a:r>
           </a:p>
         </p:txBody>
@@ -4202,7 +4253,7 @@
           <p:cNvPr id="2" name="标题 1">
             <a:extLst>
               <a:ext uri="{FF2B5EF4-FFF2-40B4-BE49-F238E27FC236}">
-                <a16:creationId xmlns:a16="http://schemas.microsoft.com/office/drawing/2014/main" xmlns="" id="{D7480D64-317E-4CDC-AC3D-D2C7B3043F1C}"/>
+                <a16:creationId xmlns:a16="http://schemas.microsoft.com/office/drawing/2014/main" id="{D7480D64-317E-4CDC-AC3D-D2C7B3043F1C}"/>
               </a:ext>
             </a:extLst>
           </p:cNvPr>
@@ -4239,7 +4290,7 @@
           <p:cNvPr id="3" name="副标题 2">
             <a:extLst>
               <a:ext uri="{FF2B5EF4-FFF2-40B4-BE49-F238E27FC236}">
-                <a16:creationId xmlns:a16="http://schemas.microsoft.com/office/drawing/2014/main" xmlns="" id="{5EB91D6E-5B97-4807-B6D0-968A9E906804}"/>
+                <a16:creationId xmlns:a16="http://schemas.microsoft.com/office/drawing/2014/main" id="{5EB91D6E-5B97-4807-B6D0-968A9E906804}"/>
               </a:ext>
             </a:extLst>
           </p:cNvPr>
@@ -4309,7 +4360,7 @@
           <p:cNvPr id="4" name="日期占位符 3">
             <a:extLst>
               <a:ext uri="{FF2B5EF4-FFF2-40B4-BE49-F238E27FC236}">
-                <a16:creationId xmlns:a16="http://schemas.microsoft.com/office/drawing/2014/main" xmlns="" id="{5D310CCC-0982-457B-818E-E81A818515DD}"/>
+                <a16:creationId xmlns:a16="http://schemas.microsoft.com/office/drawing/2014/main" id="{5D310CCC-0982-457B-818E-E81A818515DD}"/>
               </a:ext>
             </a:extLst>
           </p:cNvPr>
@@ -4327,7 +4378,7 @@
           <a:p>
             <a:fld id="{E85436C5-9152-4786-A91A-3104E50E2970}" type="datetimeFigureOut">
               <a:rPr lang="zh-CN" altLang="en-US" smtClean="0"/>
-              <a:t>2026/10/24</a:t>
+              <a:t>2026/10/30</a:t>
             </a:fld>
             <a:endParaRPr lang="zh-CN" altLang="en-US"/>
           </a:p>
@@ -4338,7 +4389,7 @@
           <p:cNvPr id="5" name="页脚占位符 4">
             <a:extLst>
               <a:ext uri="{FF2B5EF4-FFF2-40B4-BE49-F238E27FC236}">
-                <a16:creationId xmlns:a16="http://schemas.microsoft.com/office/drawing/2014/main" xmlns="" id="{C7D4BD65-7F98-4F6D-9A61-55C6CB8E76A2}"/>
+                <a16:creationId xmlns:a16="http://schemas.microsoft.com/office/drawing/2014/main" id="{C7D4BD65-7F98-4F6D-9A61-55C6CB8E76A2}"/>
               </a:ext>
             </a:extLst>
           </p:cNvPr>
@@ -4363,7 +4414,7 @@
           <p:cNvPr id="6" name="灯片编号占位符 5">
             <a:extLst>
               <a:ext uri="{FF2B5EF4-FFF2-40B4-BE49-F238E27FC236}">
-                <a16:creationId xmlns:a16="http://schemas.microsoft.com/office/drawing/2014/main" xmlns="" id="{DD8281E2-9B4B-4A23-BB3B-8FBDF21B5AB7}"/>
+                <a16:creationId xmlns:a16="http://schemas.microsoft.com/office/drawing/2014/main" id="{DD8281E2-9B4B-4A23-BB3B-8FBDF21B5AB7}"/>
               </a:ext>
             </a:extLst>
           </p:cNvPr>
@@ -4392,7 +4443,7 @@
           <p:cNvPr id="7" name="组合 6">
             <a:extLst>
               <a:ext uri="{FF2B5EF4-FFF2-40B4-BE49-F238E27FC236}">
-                <a16:creationId xmlns:a16="http://schemas.microsoft.com/office/drawing/2014/main" xmlns="" id="{D87ED19F-753E-4FF4-B34F-850C84A97253}"/>
+                <a16:creationId xmlns:a16="http://schemas.microsoft.com/office/drawing/2014/main" id="{D87ED19F-753E-4FF4-B34F-850C84A97253}"/>
               </a:ext>
             </a:extLst>
           </p:cNvPr>
@@ -4412,7 +4463,7 @@
             <p:cNvPr id="8" name="图片 7" descr="60a430b5197f53b78c468f7ac7367bd2.jpg@h_1280">
               <a:extLst>
                 <a:ext uri="{FF2B5EF4-FFF2-40B4-BE49-F238E27FC236}">
-                  <a16:creationId xmlns:a16="http://schemas.microsoft.com/office/drawing/2014/main" xmlns="" id="{D615722D-08ED-4344-BCCE-24E74DB6BE70}"/>
+                  <a16:creationId xmlns:a16="http://schemas.microsoft.com/office/drawing/2014/main" id="{D615722D-08ED-4344-BCCE-24E74DB6BE70}"/>
                 </a:ext>
               </a:extLst>
             </p:cNvPr>
@@ -4449,7 +4500,7 @@
             <p:cNvPr id="9" name="图片 8" descr="图片1-removebg">
               <a:extLst>
                 <a:ext uri="{FF2B5EF4-FFF2-40B4-BE49-F238E27FC236}">
-                  <a16:creationId xmlns:a16="http://schemas.microsoft.com/office/drawing/2014/main" xmlns="" id="{EA0260EC-D01A-414B-8967-8A43F6FD4C77}"/>
+                  <a16:creationId xmlns:a16="http://schemas.microsoft.com/office/drawing/2014/main" id="{EA0260EC-D01A-414B-8967-8A43F6FD4C77}"/>
                 </a:ext>
               </a:extLst>
             </p:cNvPr>
@@ -4486,7 +4537,7 @@
           <p:cNvPr id="10" name="图片 9">
             <a:extLst>
               <a:ext uri="{FF2B5EF4-FFF2-40B4-BE49-F238E27FC236}">
-                <a16:creationId xmlns:a16="http://schemas.microsoft.com/office/drawing/2014/main" xmlns="" id="{6A921A62-1065-4227-9D38-C6300A8019C7}"/>
+                <a16:creationId xmlns:a16="http://schemas.microsoft.com/office/drawing/2014/main" id="{6A921A62-1065-4227-9D38-C6300A8019C7}"/>
               </a:ext>
             </a:extLst>
           </p:cNvPr>
@@ -4550,7 +4601,7 @@
           <p:cNvPr id="2" name="标题 1">
             <a:extLst>
               <a:ext uri="{FF2B5EF4-FFF2-40B4-BE49-F238E27FC236}">
-                <a16:creationId xmlns:a16="http://schemas.microsoft.com/office/drawing/2014/main" xmlns="" id="{19BB6604-BB7C-43AA-9405-907C9984BF02}"/>
+                <a16:creationId xmlns:a16="http://schemas.microsoft.com/office/drawing/2014/main" id="{19BB6604-BB7C-43AA-9405-907C9984BF02}"/>
               </a:ext>
             </a:extLst>
           </p:cNvPr>
@@ -4578,7 +4629,7 @@
           <p:cNvPr id="3" name="竖排文字占位符 2">
             <a:extLst>
               <a:ext uri="{FF2B5EF4-FFF2-40B4-BE49-F238E27FC236}">
-                <a16:creationId xmlns:a16="http://schemas.microsoft.com/office/drawing/2014/main" xmlns="" id="{498F31F2-CEBB-49D4-A1E3-D04CADDFDBA0}"/>
+                <a16:creationId xmlns:a16="http://schemas.microsoft.com/office/drawing/2014/main" id="{498F31F2-CEBB-49D4-A1E3-D04CADDFDBA0}"/>
               </a:ext>
             </a:extLst>
           </p:cNvPr>
@@ -4635,7 +4686,7 @@
           <p:cNvPr id="4" name="日期占位符 3">
             <a:extLst>
               <a:ext uri="{FF2B5EF4-FFF2-40B4-BE49-F238E27FC236}">
-                <a16:creationId xmlns:a16="http://schemas.microsoft.com/office/drawing/2014/main" xmlns="" id="{0BF3D28D-29B2-4555-BDA4-4450D626E1CF}"/>
+                <a16:creationId xmlns:a16="http://schemas.microsoft.com/office/drawing/2014/main" id="{0BF3D28D-29B2-4555-BDA4-4450D626E1CF}"/>
               </a:ext>
             </a:extLst>
           </p:cNvPr>
@@ -4653,7 +4704,7 @@
           <a:p>
             <a:fld id="{E85436C5-9152-4786-A91A-3104E50E2970}" type="datetimeFigureOut">
               <a:rPr lang="zh-CN" altLang="en-US" smtClean="0"/>
-              <a:t>2026/10/24</a:t>
+              <a:t>2026/10/30</a:t>
             </a:fld>
             <a:endParaRPr lang="zh-CN" altLang="en-US"/>
           </a:p>
@@ -4664,7 +4715,7 @@
           <p:cNvPr id="5" name="页脚占位符 4">
             <a:extLst>
               <a:ext uri="{FF2B5EF4-FFF2-40B4-BE49-F238E27FC236}">
-                <a16:creationId xmlns:a16="http://schemas.microsoft.com/office/drawing/2014/main" xmlns="" id="{F9D5CF20-1940-464E-A9A6-C3FB586F62EA}"/>
+                <a16:creationId xmlns:a16="http://schemas.microsoft.com/office/drawing/2014/main" id="{F9D5CF20-1940-464E-A9A6-C3FB586F62EA}"/>
               </a:ext>
             </a:extLst>
           </p:cNvPr>
@@ -4689,7 +4740,7 @@
           <p:cNvPr id="6" name="灯片编号占位符 5">
             <a:extLst>
               <a:ext uri="{FF2B5EF4-FFF2-40B4-BE49-F238E27FC236}">
-                <a16:creationId xmlns:a16="http://schemas.microsoft.com/office/drawing/2014/main" xmlns="" id="{A9DB8503-5443-4A8C-A6D8-8560AAD42FFA}"/>
+                <a16:creationId xmlns:a16="http://schemas.microsoft.com/office/drawing/2014/main" id="{A9DB8503-5443-4A8C-A6D8-8560AAD42FFA}"/>
               </a:ext>
             </a:extLst>
           </p:cNvPr>
@@ -4748,7 +4799,7 @@
           <p:cNvPr id="2" name="竖排标题 1">
             <a:extLst>
               <a:ext uri="{FF2B5EF4-FFF2-40B4-BE49-F238E27FC236}">
-                <a16:creationId xmlns:a16="http://schemas.microsoft.com/office/drawing/2014/main" xmlns="" id="{BF359C32-BF61-42EE-8041-FD0E11CACD60}"/>
+                <a16:creationId xmlns:a16="http://schemas.microsoft.com/office/drawing/2014/main" id="{BF359C32-BF61-42EE-8041-FD0E11CACD60}"/>
               </a:ext>
             </a:extLst>
           </p:cNvPr>
@@ -4781,7 +4832,7 @@
           <p:cNvPr id="3" name="竖排文字占位符 2">
             <a:extLst>
               <a:ext uri="{FF2B5EF4-FFF2-40B4-BE49-F238E27FC236}">
-                <a16:creationId xmlns:a16="http://schemas.microsoft.com/office/drawing/2014/main" xmlns="" id="{D35C5A70-DA77-423A-985B-350D277A932C}"/>
+                <a16:creationId xmlns:a16="http://schemas.microsoft.com/office/drawing/2014/main" id="{D35C5A70-DA77-423A-985B-350D277A932C}"/>
               </a:ext>
             </a:extLst>
           </p:cNvPr>
@@ -4843,7 +4894,7 @@
           <p:cNvPr id="4" name="日期占位符 3">
             <a:extLst>
               <a:ext uri="{FF2B5EF4-FFF2-40B4-BE49-F238E27FC236}">
-                <a16:creationId xmlns:a16="http://schemas.microsoft.com/office/drawing/2014/main" xmlns="" id="{190B70F9-5E01-46E9-94C6-9D2615A04E54}"/>
+                <a16:creationId xmlns:a16="http://schemas.microsoft.com/office/drawing/2014/main" id="{190B70F9-5E01-46E9-94C6-9D2615A04E54}"/>
               </a:ext>
             </a:extLst>
           </p:cNvPr>
@@ -4861,7 +4912,7 @@
           <a:p>
             <a:fld id="{E85436C5-9152-4786-A91A-3104E50E2970}" type="datetimeFigureOut">
               <a:rPr lang="zh-CN" altLang="en-US" smtClean="0"/>
-              <a:t>2026/10/24</a:t>
+              <a:t>2026/10/30</a:t>
             </a:fld>
             <a:endParaRPr lang="zh-CN" altLang="en-US"/>
           </a:p>
@@ -4872,7 +4923,7 @@
           <p:cNvPr id="5" name="页脚占位符 4">
             <a:extLst>
               <a:ext uri="{FF2B5EF4-FFF2-40B4-BE49-F238E27FC236}">
-                <a16:creationId xmlns:a16="http://schemas.microsoft.com/office/drawing/2014/main" xmlns="" id="{FD4F2FF6-970A-49D2-9E7E-EEAED099113A}"/>
+                <a16:creationId xmlns:a16="http://schemas.microsoft.com/office/drawing/2014/main" id="{FD4F2FF6-970A-49D2-9E7E-EEAED099113A}"/>
               </a:ext>
             </a:extLst>
           </p:cNvPr>
@@ -4897,7 +4948,7 @@
           <p:cNvPr id="6" name="灯片编号占位符 5">
             <a:extLst>
               <a:ext uri="{FF2B5EF4-FFF2-40B4-BE49-F238E27FC236}">
-                <a16:creationId xmlns:a16="http://schemas.microsoft.com/office/drawing/2014/main" xmlns="" id="{D734604C-3C57-4694-9853-3E35079D13CF}"/>
+                <a16:creationId xmlns:a16="http://schemas.microsoft.com/office/drawing/2014/main" id="{D734604C-3C57-4694-9853-3E35079D13CF}"/>
               </a:ext>
             </a:extLst>
           </p:cNvPr>
@@ -4998,7 +5049,7 @@
           <p:cNvPr id="3" name="内容占位符 2">
             <a:extLst>
               <a:ext uri="{FF2B5EF4-FFF2-40B4-BE49-F238E27FC236}">
-                <a16:creationId xmlns:a16="http://schemas.microsoft.com/office/drawing/2014/main" xmlns="" id="{7BD3E6BA-5ABE-461A-A503-A11F4528B535}"/>
+                <a16:creationId xmlns:a16="http://schemas.microsoft.com/office/drawing/2014/main" id="{7BD3E6BA-5ABE-461A-A503-A11F4528B535}"/>
               </a:ext>
             </a:extLst>
           </p:cNvPr>
@@ -5055,7 +5106,7 @@
           <p:cNvPr id="2" name="标题 1">
             <a:extLst>
               <a:ext uri="{FF2B5EF4-FFF2-40B4-BE49-F238E27FC236}">
-                <a16:creationId xmlns:a16="http://schemas.microsoft.com/office/drawing/2014/main" xmlns="" id="{2F07F021-0039-4458-BC5C-BC28AE74BFAC}"/>
+                <a16:creationId xmlns:a16="http://schemas.microsoft.com/office/drawing/2014/main" id="{2F07F021-0039-4458-BC5C-BC28AE74BFAC}"/>
               </a:ext>
             </a:extLst>
           </p:cNvPr>
@@ -5083,7 +5134,7 @@
           <p:cNvPr id="5" name="页脚占位符 4">
             <a:extLst>
               <a:ext uri="{FF2B5EF4-FFF2-40B4-BE49-F238E27FC236}">
-                <a16:creationId xmlns:a16="http://schemas.microsoft.com/office/drawing/2014/main" xmlns="" id="{401AF2C7-3291-40DC-B638-707E71B3D917}"/>
+                <a16:creationId xmlns:a16="http://schemas.microsoft.com/office/drawing/2014/main" id="{401AF2C7-3291-40DC-B638-707E71B3D917}"/>
               </a:ext>
             </a:extLst>
           </p:cNvPr>
@@ -5108,7 +5159,7 @@
           <p:cNvPr id="6" name="灯片编号占位符 5">
             <a:extLst>
               <a:ext uri="{FF2B5EF4-FFF2-40B4-BE49-F238E27FC236}">
-                <a16:creationId xmlns:a16="http://schemas.microsoft.com/office/drawing/2014/main" xmlns="" id="{22BD980D-A463-480F-9D3F-6B9347EF0923}"/>
+                <a16:creationId xmlns:a16="http://schemas.microsoft.com/office/drawing/2014/main" id="{22BD980D-A463-480F-9D3F-6B9347EF0923}"/>
               </a:ext>
             </a:extLst>
           </p:cNvPr>
@@ -5167,7 +5218,7 @@
           <p:cNvPr id="2" name="标题 1">
             <a:extLst>
               <a:ext uri="{FF2B5EF4-FFF2-40B4-BE49-F238E27FC236}">
-                <a16:creationId xmlns:a16="http://schemas.microsoft.com/office/drawing/2014/main" xmlns="" id="{7DAA83F0-5A51-45E9-9EA2-93DE030966F6}"/>
+                <a16:creationId xmlns:a16="http://schemas.microsoft.com/office/drawing/2014/main" id="{7DAA83F0-5A51-45E9-9EA2-93DE030966F6}"/>
               </a:ext>
             </a:extLst>
           </p:cNvPr>
@@ -5204,7 +5255,7 @@
           <p:cNvPr id="3" name="文本占位符 2">
             <a:extLst>
               <a:ext uri="{FF2B5EF4-FFF2-40B4-BE49-F238E27FC236}">
-                <a16:creationId xmlns:a16="http://schemas.microsoft.com/office/drawing/2014/main" xmlns="" id="{3799D4A9-4458-418C-8929-C1226686F247}"/>
+                <a16:creationId xmlns:a16="http://schemas.microsoft.com/office/drawing/2014/main" id="{3799D4A9-4458-418C-8929-C1226686F247}"/>
               </a:ext>
             </a:extLst>
           </p:cNvPr>
@@ -5329,7 +5380,7 @@
           <p:cNvPr id="4" name="日期占位符 3">
             <a:extLst>
               <a:ext uri="{FF2B5EF4-FFF2-40B4-BE49-F238E27FC236}">
-                <a16:creationId xmlns:a16="http://schemas.microsoft.com/office/drawing/2014/main" xmlns="" id="{79B8FC71-1626-422B-A5F5-CCA04C45EBB8}"/>
+                <a16:creationId xmlns:a16="http://schemas.microsoft.com/office/drawing/2014/main" id="{79B8FC71-1626-422B-A5F5-CCA04C45EBB8}"/>
               </a:ext>
             </a:extLst>
           </p:cNvPr>
@@ -5347,7 +5398,7 @@
           <a:p>
             <a:fld id="{E85436C5-9152-4786-A91A-3104E50E2970}" type="datetimeFigureOut">
               <a:rPr lang="zh-CN" altLang="en-US" smtClean="0"/>
-              <a:t>2026/10/24</a:t>
+              <a:t>2026/10/30</a:t>
             </a:fld>
             <a:endParaRPr lang="zh-CN" altLang="en-US"/>
           </a:p>
@@ -5358,7 +5409,7 @@
           <p:cNvPr id="5" name="页脚占位符 4">
             <a:extLst>
               <a:ext uri="{FF2B5EF4-FFF2-40B4-BE49-F238E27FC236}">
-                <a16:creationId xmlns:a16="http://schemas.microsoft.com/office/drawing/2014/main" xmlns="" id="{3D8F03E1-356F-44E4-AC12-0936A2BD41E6}"/>
+                <a16:creationId xmlns:a16="http://schemas.microsoft.com/office/drawing/2014/main" id="{3D8F03E1-356F-44E4-AC12-0936A2BD41E6}"/>
               </a:ext>
             </a:extLst>
           </p:cNvPr>
@@ -5383,7 +5434,7 @@
           <p:cNvPr id="6" name="灯片编号占位符 5">
             <a:extLst>
               <a:ext uri="{FF2B5EF4-FFF2-40B4-BE49-F238E27FC236}">
-                <a16:creationId xmlns:a16="http://schemas.microsoft.com/office/drawing/2014/main" xmlns="" id="{6C17C97A-1973-4C7E-A746-EEC9B889FEAC}"/>
+                <a16:creationId xmlns:a16="http://schemas.microsoft.com/office/drawing/2014/main" id="{6C17C97A-1973-4C7E-A746-EEC9B889FEAC}"/>
               </a:ext>
             </a:extLst>
           </p:cNvPr>
@@ -5442,7 +5493,7 @@
           <p:cNvPr id="2" name="标题 1">
             <a:extLst>
               <a:ext uri="{FF2B5EF4-FFF2-40B4-BE49-F238E27FC236}">
-                <a16:creationId xmlns:a16="http://schemas.microsoft.com/office/drawing/2014/main" xmlns="" id="{0B364678-535B-4151-93CE-41FAFFD80F70}"/>
+                <a16:creationId xmlns:a16="http://schemas.microsoft.com/office/drawing/2014/main" id="{0B364678-535B-4151-93CE-41FAFFD80F70}"/>
               </a:ext>
             </a:extLst>
           </p:cNvPr>
@@ -5470,7 +5521,7 @@
           <p:cNvPr id="3" name="内容占位符 2">
             <a:extLst>
               <a:ext uri="{FF2B5EF4-FFF2-40B4-BE49-F238E27FC236}">
-                <a16:creationId xmlns:a16="http://schemas.microsoft.com/office/drawing/2014/main" xmlns="" id="{14E0F224-75A7-42CB-948F-F0719F4B12ED}"/>
+                <a16:creationId xmlns:a16="http://schemas.microsoft.com/office/drawing/2014/main" id="{14E0F224-75A7-42CB-948F-F0719F4B12ED}"/>
               </a:ext>
             </a:extLst>
           </p:cNvPr>
@@ -5532,7 +5583,7 @@
           <p:cNvPr id="4" name="内容占位符 3">
             <a:extLst>
               <a:ext uri="{FF2B5EF4-FFF2-40B4-BE49-F238E27FC236}">
-                <a16:creationId xmlns:a16="http://schemas.microsoft.com/office/drawing/2014/main" xmlns="" id="{8011AC57-CB7C-43ED-ADA2-4BF856943423}"/>
+                <a16:creationId xmlns:a16="http://schemas.microsoft.com/office/drawing/2014/main" id="{8011AC57-CB7C-43ED-ADA2-4BF856943423}"/>
               </a:ext>
             </a:extLst>
           </p:cNvPr>
@@ -5594,7 +5645,7 @@
           <p:cNvPr id="5" name="日期占位符 4">
             <a:extLst>
               <a:ext uri="{FF2B5EF4-FFF2-40B4-BE49-F238E27FC236}">
-                <a16:creationId xmlns:a16="http://schemas.microsoft.com/office/drawing/2014/main" xmlns="" id="{28A62DE2-D7D9-4CC1-BC59-6A99B0F75D6B}"/>
+                <a16:creationId xmlns:a16="http://schemas.microsoft.com/office/drawing/2014/main" id="{28A62DE2-D7D9-4CC1-BC59-6A99B0F75D6B}"/>
               </a:ext>
             </a:extLst>
           </p:cNvPr>
@@ -5612,7 +5663,7 @@
           <a:p>
             <a:fld id="{E85436C5-9152-4786-A91A-3104E50E2970}" type="datetimeFigureOut">
               <a:rPr lang="zh-CN" altLang="en-US" smtClean="0"/>
-              <a:t>2026/10/24</a:t>
+              <a:t>2026/10/30</a:t>
             </a:fld>
             <a:endParaRPr lang="zh-CN" altLang="en-US"/>
           </a:p>
@@ -5623,7 +5674,7 @@
           <p:cNvPr id="6" name="页脚占位符 5">
             <a:extLst>
               <a:ext uri="{FF2B5EF4-FFF2-40B4-BE49-F238E27FC236}">
-                <a16:creationId xmlns:a16="http://schemas.microsoft.com/office/drawing/2014/main" xmlns="" id="{814802EB-1D24-4499-BB0C-3C9EF9720717}"/>
+                <a16:creationId xmlns:a16="http://schemas.microsoft.com/office/drawing/2014/main" id="{814802EB-1D24-4499-BB0C-3C9EF9720717}"/>
               </a:ext>
             </a:extLst>
           </p:cNvPr>
@@ -5648,7 +5699,7 @@
           <p:cNvPr id="7" name="灯片编号占位符 6">
             <a:extLst>
               <a:ext uri="{FF2B5EF4-FFF2-40B4-BE49-F238E27FC236}">
-                <a16:creationId xmlns:a16="http://schemas.microsoft.com/office/drawing/2014/main" xmlns="" id="{4F913A9F-12BF-47E8-B4BA-DD77A2857A9E}"/>
+                <a16:creationId xmlns:a16="http://schemas.microsoft.com/office/drawing/2014/main" id="{4F913A9F-12BF-47E8-B4BA-DD77A2857A9E}"/>
               </a:ext>
             </a:extLst>
           </p:cNvPr>
@@ -5707,7 +5758,7 @@
           <p:cNvPr id="2" name="标题 1">
             <a:extLst>
               <a:ext uri="{FF2B5EF4-FFF2-40B4-BE49-F238E27FC236}">
-                <a16:creationId xmlns:a16="http://schemas.microsoft.com/office/drawing/2014/main" xmlns="" id="{A27308AA-766B-43B8-9A45-C9B72EEA9347}"/>
+                <a16:creationId xmlns:a16="http://schemas.microsoft.com/office/drawing/2014/main" id="{A27308AA-766B-43B8-9A45-C9B72EEA9347}"/>
               </a:ext>
             </a:extLst>
           </p:cNvPr>
@@ -5740,7 +5791,7 @@
           <p:cNvPr id="3" name="文本占位符 2">
             <a:extLst>
               <a:ext uri="{FF2B5EF4-FFF2-40B4-BE49-F238E27FC236}">
-                <a16:creationId xmlns:a16="http://schemas.microsoft.com/office/drawing/2014/main" xmlns="" id="{22C0D2F3-55A1-4971-8728-81EB6CCD8E67}"/>
+                <a16:creationId xmlns:a16="http://schemas.microsoft.com/office/drawing/2014/main" id="{22C0D2F3-55A1-4971-8728-81EB6CCD8E67}"/>
               </a:ext>
             </a:extLst>
           </p:cNvPr>
@@ -5811,7 +5862,7 @@
           <p:cNvPr id="4" name="内容占位符 3">
             <a:extLst>
               <a:ext uri="{FF2B5EF4-FFF2-40B4-BE49-F238E27FC236}">
-                <a16:creationId xmlns:a16="http://schemas.microsoft.com/office/drawing/2014/main" xmlns="" id="{CA246B8F-4493-411C-9211-C619CFFE2137}"/>
+                <a16:creationId xmlns:a16="http://schemas.microsoft.com/office/drawing/2014/main" id="{CA246B8F-4493-411C-9211-C619CFFE2137}"/>
               </a:ext>
             </a:extLst>
           </p:cNvPr>
@@ -5873,7 +5924,7 @@
           <p:cNvPr id="5" name="文本占位符 4">
             <a:extLst>
               <a:ext uri="{FF2B5EF4-FFF2-40B4-BE49-F238E27FC236}">
-                <a16:creationId xmlns:a16="http://schemas.microsoft.com/office/drawing/2014/main" xmlns="" id="{0538907A-055F-4E2F-B3F3-36F64DE460DB}"/>
+                <a16:creationId xmlns:a16="http://schemas.microsoft.com/office/drawing/2014/main" id="{0538907A-055F-4E2F-B3F3-36F64DE460DB}"/>
               </a:ext>
             </a:extLst>
           </p:cNvPr>
@@ -5944,7 +5995,7 @@
           <p:cNvPr id="6" name="内容占位符 5">
             <a:extLst>
               <a:ext uri="{FF2B5EF4-FFF2-40B4-BE49-F238E27FC236}">
-                <a16:creationId xmlns:a16="http://schemas.microsoft.com/office/drawing/2014/main" xmlns="" id="{26DF976B-72CA-4519-9719-DB173B2DF974}"/>
+                <a16:creationId xmlns:a16="http://schemas.microsoft.com/office/drawing/2014/main" id="{26DF976B-72CA-4519-9719-DB173B2DF974}"/>
               </a:ext>
             </a:extLst>
           </p:cNvPr>
@@ -6006,7 +6057,7 @@
           <p:cNvPr id="7" name="日期占位符 6">
             <a:extLst>
               <a:ext uri="{FF2B5EF4-FFF2-40B4-BE49-F238E27FC236}">
-                <a16:creationId xmlns:a16="http://schemas.microsoft.com/office/drawing/2014/main" xmlns="" id="{792B34F3-B8FF-4FB8-8CD1-CD0D21F4D6A5}"/>
+                <a16:creationId xmlns:a16="http://schemas.microsoft.com/office/drawing/2014/main" id="{792B34F3-B8FF-4FB8-8CD1-CD0D21F4D6A5}"/>
               </a:ext>
             </a:extLst>
           </p:cNvPr>
@@ -6024,7 +6075,7 @@
           <a:p>
             <a:fld id="{E85436C5-9152-4786-A91A-3104E50E2970}" type="datetimeFigureOut">
               <a:rPr lang="zh-CN" altLang="en-US" smtClean="0"/>
-              <a:t>2026/10/24</a:t>
+              <a:t>2026/10/30</a:t>
             </a:fld>
             <a:endParaRPr lang="zh-CN" altLang="en-US"/>
           </a:p>
@@ -6035,7 +6086,7 @@
           <p:cNvPr id="8" name="页脚占位符 7">
             <a:extLst>
               <a:ext uri="{FF2B5EF4-FFF2-40B4-BE49-F238E27FC236}">
-                <a16:creationId xmlns:a16="http://schemas.microsoft.com/office/drawing/2014/main" xmlns="" id="{7A72AD91-8399-40CE-A3FC-601CA4A9ED08}"/>
+                <a16:creationId xmlns:a16="http://schemas.microsoft.com/office/drawing/2014/main" id="{7A72AD91-8399-40CE-A3FC-601CA4A9ED08}"/>
               </a:ext>
             </a:extLst>
           </p:cNvPr>
@@ -6060,7 +6111,7 @@
           <p:cNvPr id="9" name="灯片编号占位符 8">
             <a:extLst>
               <a:ext uri="{FF2B5EF4-FFF2-40B4-BE49-F238E27FC236}">
-                <a16:creationId xmlns:a16="http://schemas.microsoft.com/office/drawing/2014/main" xmlns="" id="{5D0704F5-2B8C-4526-B29B-DC7B262E6170}"/>
+                <a16:creationId xmlns:a16="http://schemas.microsoft.com/office/drawing/2014/main" id="{5D0704F5-2B8C-4526-B29B-DC7B262E6170}"/>
               </a:ext>
             </a:extLst>
           </p:cNvPr>
@@ -6119,7 +6170,7 @@
           <p:cNvPr id="2" name="标题 1">
             <a:extLst>
               <a:ext uri="{FF2B5EF4-FFF2-40B4-BE49-F238E27FC236}">
-                <a16:creationId xmlns:a16="http://schemas.microsoft.com/office/drawing/2014/main" xmlns="" id="{0BF0BAC5-C851-4B19-BD1F-103359D1FF5B}"/>
+                <a16:creationId xmlns:a16="http://schemas.microsoft.com/office/drawing/2014/main" id="{0BF0BAC5-C851-4B19-BD1F-103359D1FF5B}"/>
               </a:ext>
             </a:extLst>
           </p:cNvPr>
@@ -6147,7 +6198,7 @@
           <p:cNvPr id="3" name="日期占位符 2">
             <a:extLst>
               <a:ext uri="{FF2B5EF4-FFF2-40B4-BE49-F238E27FC236}">
-                <a16:creationId xmlns:a16="http://schemas.microsoft.com/office/drawing/2014/main" xmlns="" id="{E109B2A4-3756-467D-A6EE-258FBBF2E8C7}"/>
+                <a16:creationId xmlns:a16="http://schemas.microsoft.com/office/drawing/2014/main" id="{E109B2A4-3756-467D-A6EE-258FBBF2E8C7}"/>
               </a:ext>
             </a:extLst>
           </p:cNvPr>
@@ -6165,7 +6216,7 @@
           <a:p>
             <a:fld id="{E85436C5-9152-4786-A91A-3104E50E2970}" type="datetimeFigureOut">
               <a:rPr lang="zh-CN" altLang="en-US" smtClean="0"/>
-              <a:t>2026/10/24</a:t>
+              <a:t>2026/10/30</a:t>
             </a:fld>
             <a:endParaRPr lang="zh-CN" altLang="en-US"/>
           </a:p>
@@ -6176,7 +6227,7 @@
           <p:cNvPr id="4" name="页脚占位符 3">
             <a:extLst>
               <a:ext uri="{FF2B5EF4-FFF2-40B4-BE49-F238E27FC236}">
-                <a16:creationId xmlns:a16="http://schemas.microsoft.com/office/drawing/2014/main" xmlns="" id="{9D500D88-C96D-4923-80B1-3331EADCFD04}"/>
+                <a16:creationId xmlns:a16="http://schemas.microsoft.com/office/drawing/2014/main" id="{9D500D88-C96D-4923-80B1-3331EADCFD04}"/>
               </a:ext>
             </a:extLst>
           </p:cNvPr>
@@ -6201,7 +6252,7 @@
           <p:cNvPr id="5" name="灯片编号占位符 4">
             <a:extLst>
               <a:ext uri="{FF2B5EF4-FFF2-40B4-BE49-F238E27FC236}">
-                <a16:creationId xmlns:a16="http://schemas.microsoft.com/office/drawing/2014/main" xmlns="" id="{566B170F-C39A-46E7-9415-69265FE0950D}"/>
+                <a16:creationId xmlns:a16="http://schemas.microsoft.com/office/drawing/2014/main" id="{566B170F-C39A-46E7-9415-69265FE0950D}"/>
               </a:ext>
             </a:extLst>
           </p:cNvPr>
@@ -6260,7 +6311,7 @@
           <p:cNvPr id="2" name="日期占位符 1">
             <a:extLst>
               <a:ext uri="{FF2B5EF4-FFF2-40B4-BE49-F238E27FC236}">
-                <a16:creationId xmlns:a16="http://schemas.microsoft.com/office/drawing/2014/main" xmlns="" id="{FDC57BB7-D8DC-4D46-A346-A3DAA53D0078}"/>
+                <a16:creationId xmlns:a16="http://schemas.microsoft.com/office/drawing/2014/main" id="{FDC57BB7-D8DC-4D46-A346-A3DAA53D0078}"/>
               </a:ext>
             </a:extLst>
           </p:cNvPr>
@@ -6278,7 +6329,7 @@
           <a:p>
             <a:fld id="{E85436C5-9152-4786-A91A-3104E50E2970}" type="datetimeFigureOut">
               <a:rPr lang="zh-CN" altLang="en-US" smtClean="0"/>
-              <a:t>2026/10/24</a:t>
+              <a:t>2026/10/30</a:t>
             </a:fld>
             <a:endParaRPr lang="zh-CN" altLang="en-US"/>
           </a:p>
@@ -6289,7 +6340,7 @@
           <p:cNvPr id="3" name="页脚占位符 2">
             <a:extLst>
               <a:ext uri="{FF2B5EF4-FFF2-40B4-BE49-F238E27FC236}">
-                <a16:creationId xmlns:a16="http://schemas.microsoft.com/office/drawing/2014/main" xmlns="" id="{2CBB4F2A-8581-4848-8FA9-83ED3F25C0C8}"/>
+                <a16:creationId xmlns:a16="http://schemas.microsoft.com/office/drawing/2014/main" id="{2CBB4F2A-8581-4848-8FA9-83ED3F25C0C8}"/>
               </a:ext>
             </a:extLst>
           </p:cNvPr>
@@ -6314,7 +6365,7 @@
           <p:cNvPr id="4" name="灯片编号占位符 3">
             <a:extLst>
               <a:ext uri="{FF2B5EF4-FFF2-40B4-BE49-F238E27FC236}">
-                <a16:creationId xmlns:a16="http://schemas.microsoft.com/office/drawing/2014/main" xmlns="" id="{C66266C4-E17D-417C-B19C-0D31E67A272C}"/>
+                <a16:creationId xmlns:a16="http://schemas.microsoft.com/office/drawing/2014/main" id="{C66266C4-E17D-417C-B19C-0D31E67A272C}"/>
               </a:ext>
             </a:extLst>
           </p:cNvPr>
@@ -6373,7 +6424,7 @@
           <p:cNvPr id="2" name="标题 1">
             <a:extLst>
               <a:ext uri="{FF2B5EF4-FFF2-40B4-BE49-F238E27FC236}">
-                <a16:creationId xmlns:a16="http://schemas.microsoft.com/office/drawing/2014/main" xmlns="" id="{86A89DDF-D12F-4DF5-9619-2D7DF3521DAB}"/>
+                <a16:creationId xmlns:a16="http://schemas.microsoft.com/office/drawing/2014/main" id="{86A89DDF-D12F-4DF5-9619-2D7DF3521DAB}"/>
               </a:ext>
             </a:extLst>
           </p:cNvPr>
@@ -6410,7 +6461,7 @@
           <p:cNvPr id="3" name="内容占位符 2">
             <a:extLst>
               <a:ext uri="{FF2B5EF4-FFF2-40B4-BE49-F238E27FC236}">
-                <a16:creationId xmlns:a16="http://schemas.microsoft.com/office/drawing/2014/main" xmlns="" id="{8B2E10E8-AD27-4365-904E-5A1C41FECD5B}"/>
+                <a16:creationId xmlns:a16="http://schemas.microsoft.com/office/drawing/2014/main" id="{8B2E10E8-AD27-4365-904E-5A1C41FECD5B}"/>
               </a:ext>
             </a:extLst>
           </p:cNvPr>
@@ -6500,7 +6551,7 @@
           <p:cNvPr id="4" name="文本占位符 3">
             <a:extLst>
               <a:ext uri="{FF2B5EF4-FFF2-40B4-BE49-F238E27FC236}">
-                <a16:creationId xmlns:a16="http://schemas.microsoft.com/office/drawing/2014/main" xmlns="" id="{78436A3A-C32C-43B4-A8A7-B5768DF28186}"/>
+                <a16:creationId xmlns:a16="http://schemas.microsoft.com/office/drawing/2014/main" id="{78436A3A-C32C-43B4-A8A7-B5768DF28186}"/>
               </a:ext>
             </a:extLst>
           </p:cNvPr>
@@ -6571,7 +6622,7 @@
           <p:cNvPr id="5" name="日期占位符 4">
             <a:extLst>
               <a:ext uri="{FF2B5EF4-FFF2-40B4-BE49-F238E27FC236}">
-                <a16:creationId xmlns:a16="http://schemas.microsoft.com/office/drawing/2014/main" xmlns="" id="{C210FB68-9CDF-4404-8A09-D7C5A868BC7A}"/>
+                <a16:creationId xmlns:a16="http://schemas.microsoft.com/office/drawing/2014/main" id="{C210FB68-9CDF-4404-8A09-D7C5A868BC7A}"/>
               </a:ext>
             </a:extLst>
           </p:cNvPr>
@@ -6589,7 +6640,7 @@
           <a:p>
             <a:fld id="{E85436C5-9152-4786-A91A-3104E50E2970}" type="datetimeFigureOut">
               <a:rPr lang="zh-CN" altLang="en-US" smtClean="0"/>
-              <a:t>2026/10/24</a:t>
+              <a:t>2026/10/30</a:t>
             </a:fld>
             <a:endParaRPr lang="zh-CN" altLang="en-US"/>
           </a:p>
@@ -6600,7 +6651,7 @@
           <p:cNvPr id="6" name="页脚占位符 5">
             <a:extLst>
               <a:ext uri="{FF2B5EF4-FFF2-40B4-BE49-F238E27FC236}">
-                <a16:creationId xmlns:a16="http://schemas.microsoft.com/office/drawing/2014/main" xmlns="" id="{3E2BBAF0-CD6A-4354-956F-87CA45BC3897}"/>
+                <a16:creationId xmlns:a16="http://schemas.microsoft.com/office/drawing/2014/main" id="{3E2BBAF0-CD6A-4354-956F-87CA45BC3897}"/>
               </a:ext>
             </a:extLst>
           </p:cNvPr>
@@ -6625,7 +6676,7 @@
           <p:cNvPr id="7" name="灯片编号占位符 6">
             <a:extLst>
               <a:ext uri="{FF2B5EF4-FFF2-40B4-BE49-F238E27FC236}">
-                <a16:creationId xmlns:a16="http://schemas.microsoft.com/office/drawing/2014/main" xmlns="" id="{5B1D7AE7-9472-4AAA-86A4-7DFC23BC519A}"/>
+                <a16:creationId xmlns:a16="http://schemas.microsoft.com/office/drawing/2014/main" id="{5B1D7AE7-9472-4AAA-86A4-7DFC23BC519A}"/>
               </a:ext>
             </a:extLst>
           </p:cNvPr>
@@ -6684,7 +6735,7 @@
           <p:cNvPr id="2" name="标题 1">
             <a:extLst>
               <a:ext uri="{FF2B5EF4-FFF2-40B4-BE49-F238E27FC236}">
-                <a16:creationId xmlns:a16="http://schemas.microsoft.com/office/drawing/2014/main" xmlns="" id="{73B6041D-F81E-4D19-A4AB-0EA28EC208E8}"/>
+                <a16:creationId xmlns:a16="http://schemas.microsoft.com/office/drawing/2014/main" id="{73B6041D-F81E-4D19-A4AB-0EA28EC208E8}"/>
               </a:ext>
             </a:extLst>
           </p:cNvPr>
@@ -6721,7 +6772,7 @@
           <p:cNvPr id="3" name="图片占位符 2">
             <a:extLst>
               <a:ext uri="{FF2B5EF4-FFF2-40B4-BE49-F238E27FC236}">
-                <a16:creationId xmlns:a16="http://schemas.microsoft.com/office/drawing/2014/main" xmlns="" id="{169DE08D-F095-4CF2-9928-6480C42AA920}"/>
+                <a16:creationId xmlns:a16="http://schemas.microsoft.com/office/drawing/2014/main" id="{169DE08D-F095-4CF2-9928-6480C42AA920}"/>
               </a:ext>
             </a:extLst>
           </p:cNvPr>
@@ -6788,7 +6839,7 @@
           <p:cNvPr id="4" name="文本占位符 3">
             <a:extLst>
               <a:ext uri="{FF2B5EF4-FFF2-40B4-BE49-F238E27FC236}">
-                <a16:creationId xmlns:a16="http://schemas.microsoft.com/office/drawing/2014/main" xmlns="" id="{639D1476-590E-4FE7-B259-03711C15D957}"/>
+                <a16:creationId xmlns:a16="http://schemas.microsoft.com/office/drawing/2014/main" id="{639D1476-590E-4FE7-B259-03711C15D957}"/>
               </a:ext>
             </a:extLst>
           </p:cNvPr>
@@ -6859,7 +6910,7 @@
           <p:cNvPr id="5" name="日期占位符 4">
             <a:extLst>
               <a:ext uri="{FF2B5EF4-FFF2-40B4-BE49-F238E27FC236}">
-                <a16:creationId xmlns:a16="http://schemas.microsoft.com/office/drawing/2014/main" xmlns="" id="{6AC8F63E-BB43-4913-9315-5C1F49177851}"/>
+                <a16:creationId xmlns:a16="http://schemas.microsoft.com/office/drawing/2014/main" id="{6AC8F63E-BB43-4913-9315-5C1F49177851}"/>
               </a:ext>
             </a:extLst>
           </p:cNvPr>
@@ -6877,7 +6928,7 @@
           <a:p>
             <a:fld id="{E85436C5-9152-4786-A91A-3104E50E2970}" type="datetimeFigureOut">
               <a:rPr lang="zh-CN" altLang="en-US" smtClean="0"/>
-              <a:t>2026/10/24</a:t>
+              <a:t>2026/10/30</a:t>
             </a:fld>
             <a:endParaRPr lang="zh-CN" altLang="en-US"/>
           </a:p>
@@ -6888,7 +6939,7 @@
           <p:cNvPr id="6" name="页脚占位符 5">
             <a:extLst>
               <a:ext uri="{FF2B5EF4-FFF2-40B4-BE49-F238E27FC236}">
-                <a16:creationId xmlns:a16="http://schemas.microsoft.com/office/drawing/2014/main" xmlns="" id="{02C11308-11EA-43A1-9024-DECD0A6559F6}"/>
+                <a16:creationId xmlns:a16="http://schemas.microsoft.com/office/drawing/2014/main" id="{02C11308-11EA-43A1-9024-DECD0A6559F6}"/>
               </a:ext>
             </a:extLst>
           </p:cNvPr>
@@ -6913,7 +6964,7 @@
           <p:cNvPr id="7" name="灯片编号占位符 6">
             <a:extLst>
               <a:ext uri="{FF2B5EF4-FFF2-40B4-BE49-F238E27FC236}">
-                <a16:creationId xmlns:a16="http://schemas.microsoft.com/office/drawing/2014/main" xmlns="" id="{B100BBD0-103F-4DE2-9C42-044EF89045DB}"/>
+                <a16:creationId xmlns:a16="http://schemas.microsoft.com/office/drawing/2014/main" id="{B100BBD0-103F-4DE2-9C42-044EF89045DB}"/>
               </a:ext>
             </a:extLst>
           </p:cNvPr>
@@ -6977,7 +7028,7 @@
           <p:cNvPr id="2" name="标题占位符 1">
             <a:extLst>
               <a:ext uri="{FF2B5EF4-FFF2-40B4-BE49-F238E27FC236}">
-                <a16:creationId xmlns:a16="http://schemas.microsoft.com/office/drawing/2014/main" xmlns="" id="{2FD2129F-F3EF-482C-8E20-022606405D11}"/>
+                <a16:creationId xmlns:a16="http://schemas.microsoft.com/office/drawing/2014/main" id="{2FD2129F-F3EF-482C-8E20-022606405D11}"/>
               </a:ext>
             </a:extLst>
           </p:cNvPr>
@@ -7015,7 +7066,7 @@
           <p:cNvPr id="3" name="文本占位符 2">
             <a:extLst>
               <a:ext uri="{FF2B5EF4-FFF2-40B4-BE49-F238E27FC236}">
-                <a16:creationId xmlns:a16="http://schemas.microsoft.com/office/drawing/2014/main" xmlns="" id="{15F6433A-7B7C-4A5E-9782-77E706CF7735}"/>
+                <a16:creationId xmlns:a16="http://schemas.microsoft.com/office/drawing/2014/main" id="{15F6433A-7B7C-4A5E-9782-77E706CF7735}"/>
               </a:ext>
             </a:extLst>
           </p:cNvPr>
@@ -7082,7 +7133,7 @@
           <p:cNvPr id="4" name="日期占位符 3">
             <a:extLst>
               <a:ext uri="{FF2B5EF4-FFF2-40B4-BE49-F238E27FC236}">
-                <a16:creationId xmlns:a16="http://schemas.microsoft.com/office/drawing/2014/main" xmlns="" id="{D9EC70B7-C9EE-4D1E-BB75-E5E9E81B0586}"/>
+                <a16:creationId xmlns:a16="http://schemas.microsoft.com/office/drawing/2014/main" id="{D9EC70B7-C9EE-4D1E-BB75-E5E9E81B0586}"/>
               </a:ext>
             </a:extLst>
           </p:cNvPr>
@@ -7118,7 +7169,7 @@
           <a:p>
             <a:fld id="{E85436C5-9152-4786-A91A-3104E50E2970}" type="datetimeFigureOut">
               <a:rPr lang="zh-CN" altLang="en-US" smtClean="0"/>
-              <a:t>2026/10/24</a:t>
+              <a:t>2026/10/30</a:t>
             </a:fld>
             <a:endParaRPr lang="zh-CN" altLang="en-US"/>
           </a:p>
@@ -7129,7 +7180,7 @@
           <p:cNvPr id="5" name="页脚占位符 4">
             <a:extLst>
               <a:ext uri="{FF2B5EF4-FFF2-40B4-BE49-F238E27FC236}">
-                <a16:creationId xmlns:a16="http://schemas.microsoft.com/office/drawing/2014/main" xmlns="" id="{47BF4B2F-4DDB-4C7E-BD10-0B4AF975C342}"/>
+                <a16:creationId xmlns:a16="http://schemas.microsoft.com/office/drawing/2014/main" id="{47BF4B2F-4DDB-4C7E-BD10-0B4AF975C342}"/>
               </a:ext>
             </a:extLst>
           </p:cNvPr>
@@ -7172,7 +7223,7 @@
           <p:cNvPr id="6" name="灯片编号占位符 5">
             <a:extLst>
               <a:ext uri="{FF2B5EF4-FFF2-40B4-BE49-F238E27FC236}">
-                <a16:creationId xmlns:a16="http://schemas.microsoft.com/office/drawing/2014/main" xmlns="" id="{4D527A1D-FE4D-4512-BCC4-59D9C45167EF}"/>
+                <a16:creationId xmlns:a16="http://schemas.microsoft.com/office/drawing/2014/main" id="{4D527A1D-FE4D-4512-BCC4-59D9C45167EF}"/>
               </a:ext>
             </a:extLst>
           </p:cNvPr>
@@ -9158,11 +9209,11 @@
           <a:lstStyle/>
           <a:p>
             <a:r>
-              <a:rPr lang="en-US" sz="1400" b="1" dirty="0" smtClean="0"/>
+              <a:rPr lang="en-US" sz="1400" b="1" dirty="0"/>
               <a:t>FEASIBILITY</a:t>
             </a:r>
             <a:r>
-              <a:rPr lang="ru-RU" sz="1400" b="1" dirty="0" smtClean="0"/>
+              <a:rPr lang="ru-RU" sz="1400" b="1" dirty="0"/>
               <a:t> </a:t>
             </a:r>
             <a:r>
@@ -9170,16 +9221,12 @@
               <a:t>—</a:t>
             </a:r>
             <a:r>
-              <a:rPr lang="ru-RU" sz="1400" b="1" dirty="0" smtClean="0"/>
+              <a:rPr lang="ru-RU" sz="1400" b="1" dirty="0"/>
               <a:t> </a:t>
             </a:r>
             <a:r>
-              <a:rPr lang="en-US" sz="1400" i="1" dirty="0" smtClean="0"/>
-              <a:t>Can </a:t>
-            </a:r>
-            <a:r>
               <a:rPr lang="en-US" sz="1400" i="1" dirty="0"/>
-              <a:t>the recommendation be implemented?</a:t>
+              <a:t>Can the recommendation be implemented?</a:t>
             </a:r>
             <a:endParaRPr lang="en-US" sz="1400" dirty="0"/>
           </a:p>
@@ -9478,15 +9525,15 @@
               <a:t>SUITABILITY </a:t>
             </a:r>
             <a:r>
-              <a:rPr lang="ru-RU" sz="1400" b="1" dirty="0" smtClean="0"/>
+              <a:rPr lang="ru-RU" sz="1400" b="1" dirty="0"/>
               <a:t>(</a:t>
             </a:r>
             <a:r>
-              <a:rPr lang="en-US" sz="1400" b="1" dirty="0" smtClean="0"/>
+              <a:rPr lang="en-US" sz="1400" b="1" dirty="0"/>
               <a:t>PRIMARY, RQ1-RQ3</a:t>
             </a:r>
             <a:r>
-              <a:rPr lang="ru-RU" sz="1400" b="1" dirty="0" smtClean="0"/>
+              <a:rPr lang="ru-RU" sz="1400" b="1" dirty="0"/>
               <a:t>) </a:t>
             </a:r>
             <a:r>
@@ -9494,12 +9541,8 @@
               <a:t>— </a:t>
             </a:r>
             <a:r>
-              <a:rPr lang="en-US" sz="1400" i="1" dirty="0" smtClean="0"/>
-              <a:t>Does </a:t>
-            </a:r>
-            <a:r>
               <a:rPr lang="en-US" sz="1400" i="1" dirty="0"/>
-              <a:t>it fit the investor?</a:t>
+              <a:t>Does it fit the investor?</a:t>
             </a:r>
             <a:endParaRPr lang="en-US" sz="1400" dirty="0"/>
           </a:p>
@@ -9662,11 +9705,11 @@
               <a:t>(</a:t>
             </a:r>
             <a:r>
-              <a:rPr lang="en-US" sz="1400" b="1" dirty="0" smtClean="0"/>
+              <a:rPr lang="en-US" sz="1400" b="1" dirty="0"/>
               <a:t>HISTORICAL BACKTEST</a:t>
             </a:r>
             <a:r>
-              <a:rPr lang="ru-RU" sz="1400" b="1" dirty="0" smtClean="0"/>
+              <a:rPr lang="ru-RU" sz="1400" b="1" dirty="0"/>
               <a:t>) </a:t>
             </a:r>
             <a:r>
@@ -9674,12 +9717,8 @@
               <a:t>— </a:t>
             </a:r>
             <a:r>
-              <a:rPr lang="en-US" sz="1400" i="1" dirty="0" smtClean="0"/>
-              <a:t>How </a:t>
-            </a:r>
-            <a:r>
               <a:rPr lang="en-US" sz="1400" i="1" dirty="0"/>
-              <a:t>did the portfolios perform over the study period?</a:t>
+              <a:t>How did the portfolios perform over the study period?</a:t>
             </a:r>
             <a:endParaRPr lang="en-US" sz="1400" dirty="0"/>
           </a:p>
@@ -9777,20 +9816,15 @@
           <a:p>
             <a:r>
               <a:rPr lang="en-US" sz="1600" b="1" dirty="0"/>
-              <a:t>STATISTICAL </a:t>
-            </a:r>
-            <a:r>
-              <a:rPr lang="en-US" sz="1600" b="1" dirty="0" smtClean="0"/>
-              <a:t>DESIGN</a:t>
-            </a:r>
-            <a:endParaRPr lang="ru-RU" sz="1600" dirty="0" smtClean="0"/>
-          </a:p>
-          <a:p>
-            <a:r>
-              <a:rPr lang="en-US" sz="1400" dirty="0" smtClean="0"/>
+              <a:t>STATISTICAL DESIGN</a:t>
+            </a:r>
+            <a:endParaRPr lang="ru-RU" sz="1600" dirty="0"/>
+          </a:p>
+          <a:p>
+            <a:r>
+              <a:rPr lang="en-US" sz="1400" dirty="0"/>
               <a:t>Spearman, Type II ANOVA and investor-clustered OLS for RQ1 · Paired BASE-SUIT tests · Two-sided, Holm-adjusted p-values · Effect sizes first (80% power for d_z = 0.2)</a:t>
             </a:r>
-            <a:endParaRPr lang="en-US" sz="1400" dirty="0"/>
           </a:p>
         </p:txBody>
       </p:sp>
@@ -18295,7 +18329,7 @@
               </a:rPr>
               <a:t>Motivation &amp; </a:t>
             </a:r>
-            <a:endParaRPr lang="ru-RU" sz="4400" b="1" dirty="0" smtClean="0">
+            <a:endParaRPr lang="ru-RU" sz="4400" b="1" dirty="0">
               <a:solidFill>
                 <a:srgbClr val="365B7E"/>
               </a:solidFill>
@@ -18305,7 +18339,7 @@
           <a:p>
             <a:pPr algn="l"/>
             <a:r>
-              <a:rPr sz="4400" b="1" dirty="0" smtClean="0">
+              <a:rPr sz="4400" b="1" dirty="0">
                 <a:solidFill>
                   <a:srgbClr val="365B7E"/>
                 </a:solidFill>
@@ -18313,12 +18347,6 @@
               </a:rPr>
               <a:t>Questions</a:t>
             </a:r>
-            <a:endParaRPr sz="4400" b="1" dirty="0">
-              <a:solidFill>
-                <a:srgbClr val="365B7E"/>
-              </a:solidFill>
-              <a:latin typeface="Calibri"/>
-            </a:endParaRPr>
           </a:p>
         </p:txBody>
       </p:sp>

</xml_diff>